<commit_message>
update urca 2026 poster
</commit_message>
<xml_diff>
--- a/publications/urca-2026/Poster.pptx
+++ b/publications/urca-2026/Poster.pptx
@@ -14,36 +14,25 @@
   <p:notesSz cx="6950075" cy="9236075"/>
   <p:embeddedFontLst>
     <p:embeddedFont>
-      <p:font typeface="Cambria Math" panose="02040503050406030204" pitchFamily="18" charset="0"/>
+      <p:font typeface="Corbel" panose="020B0503020204020204" pitchFamily="34" charset="0"/>
       <p:regular r:id="rId4"/>
-    </p:embeddedFont>
-    <p:embeddedFont>
-      <p:font typeface="Corbel" panose="020B0503020204020204" pitchFamily="34" charset="0"/>
-      <p:regular r:id="rId5"/>
-      <p:bold r:id="rId6"/>
-      <p:italic r:id="rId7"/>
-      <p:boldItalic r:id="rId8"/>
+      <p:bold r:id="rId5"/>
+      <p:italic r:id="rId6"/>
+      <p:boldItalic r:id="rId7"/>
     </p:embeddedFont>
     <p:embeddedFont>
       <p:font typeface="EB Garamond" pitchFamily="2" charset="0"/>
-      <p:regular r:id="rId9"/>
-      <p:bold r:id="rId10"/>
-      <p:italic r:id="rId11"/>
-      <p:boldItalic r:id="rId12"/>
-    </p:embeddedFont>
-    <p:embeddedFont>
-      <p:font typeface="Helvetica Neue" panose="02000503000000020004" pitchFamily="2" charset="0"/>
-      <p:regular r:id="rId13"/>
-      <p:bold r:id="rId14"/>
-      <p:italic r:id="rId15"/>
-      <p:boldItalic r:id="rId16"/>
+      <p:regular r:id="rId8"/>
+      <p:bold r:id="rId9"/>
+      <p:italic r:id="rId10"/>
+      <p:boldItalic r:id="rId11"/>
     </p:embeddedFont>
     <p:embeddedFont>
       <p:font typeface="Verdana" panose="020B0604030504040204" pitchFamily="34" charset="0"/>
-      <p:regular r:id="rId17"/>
-      <p:bold r:id="rId18"/>
-      <p:italic r:id="rId19"/>
-      <p:boldItalic r:id="rId20"/>
+      <p:regular r:id="rId12"/>
+      <p:bold r:id="rId13"/>
+      <p:italic r:id="rId14"/>
+      <p:boldItalic r:id="rId15"/>
     </p:embeddedFont>
   </p:embeddedFontLst>
   <p:defaultTextStyle>
@@ -341,7 +330,7 @@
       </p15:sldGuideLst>
     </p:ext>
     <p:ext uri="GoogleSlidesCustomDataVersion2">
-      <go:slidesCustomData xmlns="" xmlns:mc="http://schemas.openxmlformats.org/markup-compatibility/2006" xmlns:mv="urn:schemas-microsoft-com:mac:vml" xmlns:c="http://schemas.openxmlformats.org/drawingml/2006/chart" xmlns:dgm="http://schemas.openxmlformats.org/drawingml/2006/diagram" xmlns:o="urn:schemas-microsoft-com:office:office" xmlns:v="urn:schemas-microsoft-com:vml" xmlns:pvml="urn:schemas-microsoft-com:office:powerpoint" xmlns:com="http://schemas.openxmlformats.org/drawingml/2006/compatibility" xmlns:p14="http://schemas.microsoft.com/office/powerpoint/2010/main" xmlns:p15="http://schemas.microsoft.com/office/powerpoint/2012/main" xmlns:ahyp="http://schemas.microsoft.com/office/drawing/2018/hyperlinkcolor" xmlns:go="http://customooxmlschemas.google.com/" r:id="rId21" roundtripDataSignature="AMtx7mgWSjSeOX8ykGe4GBVg+ganuGxPXw=="/>
+      <go:slidesCustomData xmlns:go="http://customooxmlschemas.google.com/" xmlns:ahyp="http://schemas.microsoft.com/office/drawing/2018/hyperlinkcolor" xmlns:p15="http://schemas.microsoft.com/office/powerpoint/2012/main" xmlns:p14="http://schemas.microsoft.com/office/powerpoint/2010/main" xmlns:com="http://schemas.openxmlformats.org/drawingml/2006/compatibility" xmlns:pvml="urn:schemas-microsoft-com:office:powerpoint" xmlns:v="urn:schemas-microsoft-com:vml" xmlns:o="urn:schemas-microsoft-com:office:office" xmlns:dgm="http://schemas.openxmlformats.org/drawingml/2006/diagram" xmlns:c="http://schemas.openxmlformats.org/drawingml/2006/chart" xmlns:mv="urn:schemas-microsoft-com:mac:vml" xmlns:mc="http://schemas.openxmlformats.org/markup-compatibility/2006" xmlns="" r:id="rId21" roundtripDataSignature="AMtx7mgWSjSeOX8ykGe4GBVg+ganuGxPXw=="/>
     </p:ext>
   </p:extLst>
 </p:presentation>
@@ -11569,7 +11558,7 @@
         <p:spPr>
           <a:xfrm>
             <a:off x="1051256" y="8891062"/>
-            <a:ext cx="9809348" cy="7478930"/>
+            <a:ext cx="9809348" cy="9787254"/>
           </a:xfrm>
           <a:prstGeom prst="rect">
             <a:avLst/>
@@ -11585,446 +11574,47 @@
           </a:bodyPr>
           <a:lstStyle/>
           <a:p>
-            <a:pPr marL="0" marR="0" lvl="0" indent="0" algn="just" rtl="0">
-              <a:spcBef>
-                <a:spcPts val="0"/>
-              </a:spcBef>
-              <a:spcAft>
-                <a:spcPts val="0"/>
-              </a:spcAft>
-              <a:buNone/>
-            </a:pPr>
             <a:r>
-              <a:rPr lang="en-US" sz="3000" b="0" i="0" u="none" strike="noStrike" cap="none" dirty="0">
-                <a:solidFill>
-                  <a:schemeClr val="accent6"/>
-                </a:solidFill>
-                <a:latin typeface="EB Garamond"/>
-                <a:ea typeface="EB Garamond"/>
-                <a:cs typeface="EB Garamond"/>
-                <a:sym typeface="EB Garamond"/>
+              <a:rPr lang="en-US" sz="3000" b="1" dirty="0">
+                <a:latin typeface="EB Garamond" pitchFamily="2" charset="0"/>
+                <a:ea typeface="EB Garamond" pitchFamily="2" charset="0"/>
               </a:rPr>
-              <a:t>This research project provides a better understanding of the impact of mission statements of tax-exempt organizations on fundraising, specifically in the United States, Australia, the United Kingdom, and Canada. We utilize the Python Requests and </a:t>
+              <a:t>Does wildfire exposure causally increase the probability and intensity of local conflict in Indonesia?</a:t>
             </a:r>
-            <a:r>
-              <a:rPr lang="en-US" sz="3000" b="0" i="0" u="none" strike="noStrike" cap="none" dirty="0" err="1">
-                <a:solidFill>
-                  <a:schemeClr val="accent6"/>
-                </a:solidFill>
-                <a:latin typeface="EB Garamond"/>
-                <a:ea typeface="EB Garamond"/>
-                <a:cs typeface="EB Garamond"/>
-                <a:sym typeface="EB Garamond"/>
-              </a:rPr>
-              <a:t>BeautifulSoup</a:t>
-            </a:r>
-            <a:r>
-              <a:rPr lang="en-US" sz="3000" b="0" i="0" u="none" strike="noStrike" cap="none" dirty="0">
-                <a:solidFill>
-                  <a:schemeClr val="accent6"/>
-                </a:solidFill>
-                <a:latin typeface="EB Garamond"/>
-                <a:ea typeface="EB Garamond"/>
-                <a:cs typeface="EB Garamond"/>
-                <a:sym typeface="EB Garamond"/>
-              </a:rPr>
-              <a:t> libraries to web scrape mission statements, names, revenue, and other relevant data from the IRS, GuideStar, and Charity Navigator. After generating the data, we use techniques drawing from Natural Language Processing (NLP) and statistics to identify patterns in mission statements across different categories of tax-exempt organizations like religious charities and medical nonprofits. NLP libraries used include Natural Language Toolkit (NLTK), Regular Expressions (</a:t>
-            </a:r>
-            <a:r>
-              <a:rPr lang="en-US" sz="3000" b="0" i="0" u="none" strike="noStrike" cap="none" dirty="0" err="1">
-                <a:solidFill>
-                  <a:schemeClr val="accent6"/>
-                </a:solidFill>
-                <a:latin typeface="EB Garamond"/>
-                <a:ea typeface="EB Garamond"/>
-                <a:cs typeface="EB Garamond"/>
-                <a:sym typeface="EB Garamond"/>
-              </a:rPr>
-              <a:t>RegEx</a:t>
-            </a:r>
-            <a:r>
-              <a:rPr lang="en-US" sz="3000" b="0" i="0" u="none" strike="noStrike" cap="none" dirty="0">
-                <a:solidFill>
-                  <a:schemeClr val="accent6"/>
-                </a:solidFill>
-                <a:latin typeface="EB Garamond"/>
-                <a:ea typeface="EB Garamond"/>
-                <a:cs typeface="EB Garamond"/>
-                <a:sym typeface="EB Garamond"/>
-              </a:rPr>
-              <a:t>), and </a:t>
-            </a:r>
-            <a:r>
-              <a:rPr lang="en-US" sz="3000" b="0" i="0" u="none" strike="noStrike" cap="none" dirty="0" err="1">
-                <a:solidFill>
-                  <a:schemeClr val="accent6"/>
-                </a:solidFill>
-                <a:latin typeface="EB Garamond"/>
-                <a:ea typeface="EB Garamond"/>
-                <a:cs typeface="EB Garamond"/>
-                <a:sym typeface="EB Garamond"/>
-              </a:rPr>
-              <a:t>SpaCy</a:t>
-            </a:r>
-            <a:r>
-              <a:rPr lang="en-US" sz="3000" b="0" i="0" u="none" strike="noStrike" cap="none" dirty="0">
-                <a:solidFill>
-                  <a:schemeClr val="accent6"/>
-                </a:solidFill>
-                <a:latin typeface="EB Garamond"/>
-                <a:ea typeface="EB Garamond"/>
-                <a:cs typeface="EB Garamond"/>
-                <a:sym typeface="EB Garamond"/>
-              </a:rPr>
-              <a:t>. In full, this project provides insight into the impact of mission statement language on fundraising efforts. All project code, data, and documentation can be found at github.com/Hariaksha/NLP-Charity-Research.</a:t>
-            </a:r>
-            <a:endParaRPr lang="en-US" dirty="0"/>
-          </a:p>
-        </p:txBody>
-      </p:sp>
-      <p:sp>
-        <p:nvSpPr>
-          <p:cNvPr id="91" name="Google Shape;91;p1"/>
-          <p:cNvSpPr txBox="1"/>
-          <p:nvPr/>
-        </p:nvSpPr>
-        <p:spPr>
-          <a:xfrm>
-            <a:off x="1051255" y="18079390"/>
-            <a:ext cx="10018879" cy="7325042"/>
-          </a:xfrm>
-          <a:prstGeom prst="rect">
-            <a:avLst/>
-          </a:prstGeom>
-          <a:noFill/>
-          <a:ln>
-            <a:noFill/>
-          </a:ln>
-        </p:spPr>
-        <p:txBody>
-          <a:bodyPr spcFirstLastPara="1" wrap="square" lIns="91425" tIns="45700" rIns="91425" bIns="45700" anchor="t" anchorCtr="0">
-            <a:spAutoFit/>
-          </a:bodyPr>
-          <a:lstStyle/>
-          <a:p>
-            <a:pPr marL="0" marR="0" lvl="0" indent="0" algn="just" rtl="0">
-              <a:spcBef>
-                <a:spcPts val="0"/>
-              </a:spcBef>
-              <a:spcAft>
-                <a:spcPts val="0"/>
-              </a:spcAft>
-              <a:buNone/>
-            </a:pPr>
-            <a:r>
-              <a:rPr lang="en-US" sz="3000" b="1" i="0" u="none" strike="noStrike" cap="none" dirty="0">
-                <a:solidFill>
-                  <a:schemeClr val="accent6"/>
-                </a:solidFill>
-                <a:latin typeface="EB Garamond"/>
-                <a:ea typeface="EB Garamond"/>
-                <a:cs typeface="EB Garamond"/>
-                <a:sym typeface="EB Garamond"/>
-              </a:rPr>
-              <a:t>Natural Language Processing:</a:t>
-            </a:r>
-            <a:endParaRPr dirty="0"/>
+            <a:endParaRPr lang="en-US" sz="3000" dirty="0">
+              <a:latin typeface="EB Garamond" pitchFamily="2" charset="0"/>
+              <a:ea typeface="EB Garamond" pitchFamily="2" charset="0"/>
+            </a:endParaRPr>
           </a:p>
           <a:p>
-            <a:pPr marL="457200" marR="0" lvl="0" indent="-457200" algn="just" rtl="0">
-              <a:spcBef>
-                <a:spcPts val="0"/>
-              </a:spcBef>
-              <a:spcAft>
-                <a:spcPts val="0"/>
-              </a:spcAft>
-              <a:buClr>
-                <a:schemeClr val="accent6"/>
-              </a:buClr>
-              <a:buSzPts val="3000"/>
-              <a:buFont typeface="Arial"/>
-              <a:buChar char="•"/>
-            </a:pPr>
+            <a:endParaRPr lang="en-US" sz="3000" dirty="0">
+              <a:latin typeface="EB Garamond" pitchFamily="2" charset="0"/>
+              <a:ea typeface="EB Garamond" pitchFamily="2" charset="0"/>
+            </a:endParaRPr>
+          </a:p>
+          <a:p>
             <a:r>
-              <a:rPr lang="en-US" sz="3000" b="0" i="0" u="none" strike="noStrike" cap="none" dirty="0">
-                <a:solidFill>
-                  <a:schemeClr val="accent6"/>
-                </a:solidFill>
-                <a:latin typeface="EB Garamond"/>
-                <a:ea typeface="EB Garamond"/>
-                <a:cs typeface="EB Garamond"/>
-                <a:sym typeface="EB Garamond"/>
+              <a:rPr lang="en-US" sz="3000" dirty="0">
+                <a:latin typeface="EB Garamond" pitchFamily="2" charset="0"/>
+                <a:ea typeface="EB Garamond" pitchFamily="2" charset="0"/>
               </a:rPr>
-              <a:t>Natural  Language Processing (NLP) is the branch of Artificial Intelligence that enables computers to understand, manipulate, and generate human language.</a:t>
+              <a:t>Indonesia's peatlands are among the most fire-prone landscapes on Earth, with large-scale burning events occurring regularly since the 1990s. Fires destroy agricultural livelihoods, displace communities, and degrade natural resources that rural populations depend on for survival. At the same time, Indonesia has a well-documented history of violent conflict tied to land disputes, resource scarcity, and displacement of indigenous communities by corporate agricultural expansion.</a:t>
             </a:r>
           </a:p>
           <a:p>
-            <a:pPr marL="457200" marR="0" lvl="0" indent="-457200" algn="just" rtl="0">
-              <a:spcBef>
-                <a:spcPts val="0"/>
-              </a:spcBef>
-              <a:spcAft>
-                <a:spcPts val="0"/>
-              </a:spcAft>
-              <a:buClr>
-                <a:schemeClr val="accent6"/>
-              </a:buClr>
-              <a:buSzPts val="3000"/>
-              <a:buFont typeface="Arial"/>
-              <a:buChar char="•"/>
-            </a:pPr>
-            <a:r>
-              <a:rPr lang="en-US" sz="3000" dirty="0">
-                <a:solidFill>
-                  <a:schemeClr val="accent6"/>
-                </a:solidFill>
-                <a:latin typeface="EB Garamond"/>
-                <a:ea typeface="EB Garamond"/>
-                <a:cs typeface="EB Garamond"/>
-                <a:sym typeface="EB Garamond"/>
-              </a:rPr>
-              <a:t>This technology is v</a:t>
-            </a:r>
-            <a:r>
-              <a:rPr lang="en-US" sz="3000" b="0" i="0" u="none" strike="noStrike" cap="none" dirty="0">
-                <a:solidFill>
-                  <a:schemeClr val="accent6"/>
-                </a:solidFill>
-                <a:latin typeface="EB Garamond"/>
-                <a:ea typeface="EB Garamond"/>
-                <a:cs typeface="EB Garamond"/>
-                <a:sym typeface="EB Garamond"/>
-              </a:rPr>
-              <a:t>ital for many applications involving unstructured and textual data.</a:t>
-            </a:r>
-            <a:endParaRPr dirty="0"/>
-          </a:p>
-          <a:p>
-            <a:pPr marL="0" marR="0" lvl="0" indent="0" algn="just" rtl="0">
-              <a:spcBef>
-                <a:spcPts val="1200"/>
-              </a:spcBef>
-              <a:spcAft>
-                <a:spcPts val="0"/>
-              </a:spcAft>
-              <a:buNone/>
-            </a:pPr>
-            <a:r>
-              <a:rPr lang="en-US" sz="3000" b="1" i="0" u="none" strike="noStrike" cap="none" dirty="0">
-                <a:solidFill>
-                  <a:schemeClr val="accent6"/>
-                </a:solidFill>
-                <a:latin typeface="EB Garamond"/>
-                <a:ea typeface="EB Garamond"/>
-                <a:cs typeface="EB Garamond"/>
-                <a:sym typeface="EB Garamond"/>
-              </a:rPr>
-              <a:t>Nonprofits in America:</a:t>
-            </a:r>
-          </a:p>
-          <a:p>
-            <a:pPr marL="457200" marR="0" lvl="0" indent="-457200" algn="just" defTabSz="914400" rtl="0" eaLnBrk="1" fontAlgn="auto" latinLnBrk="0" hangingPunct="1">
-              <a:lnSpc>
-                <a:spcPct val="100000"/>
-              </a:lnSpc>
-              <a:spcBef>
-                <a:spcPts val="0"/>
-              </a:spcBef>
-              <a:spcAft>
-                <a:spcPts val="0"/>
-              </a:spcAft>
-              <a:buClr>
-                <a:srgbClr val="000000"/>
-              </a:buClr>
-              <a:buSzPts val="3000"/>
-              <a:buFont typeface="Arial"/>
-              <a:buChar char="•"/>
-              <a:tabLst/>
-              <a:defRPr/>
-            </a:pPr>
-            <a:r>
-              <a:rPr lang="en-US" sz="3000" dirty="0">
-                <a:solidFill>
-                  <a:schemeClr val="accent6"/>
-                </a:solidFill>
-                <a:latin typeface="EB Garamond"/>
-                <a:ea typeface="EB Garamond"/>
-                <a:cs typeface="EB Garamond"/>
-                <a:sym typeface="EB Garamond"/>
-              </a:rPr>
-              <a:t>Most nonprofits are small and community-based, and 92% operate with less than $1 million a year.</a:t>
-            </a:r>
-          </a:p>
-          <a:p>
-            <a:pPr marL="457200" marR="0" lvl="0" indent="-457200" algn="just" defTabSz="914400" rtl="0" eaLnBrk="1" fontAlgn="auto" latinLnBrk="0" hangingPunct="1">
-              <a:lnSpc>
-                <a:spcPct val="100000"/>
-              </a:lnSpc>
-              <a:spcBef>
-                <a:spcPts val="0"/>
-              </a:spcBef>
-              <a:spcAft>
-                <a:spcPts val="0"/>
-              </a:spcAft>
-              <a:buClr>
-                <a:srgbClr val="000000"/>
-              </a:buClr>
-              <a:buSzPts val="3000"/>
-              <a:buFont typeface="Arial"/>
-              <a:buChar char="•"/>
-              <a:tabLst/>
-              <a:defRPr/>
-            </a:pPr>
-            <a:r>
-              <a:rPr kumimoji="0" lang="en-US" sz="3000" b="0" i="0" u="none" strike="noStrike" kern="0" cap="none" spc="0" normalizeH="0" baseline="0" noProof="0" dirty="0">
-                <a:ln>
-                  <a:noFill/>
-                </a:ln>
-                <a:solidFill>
-                  <a:schemeClr val="accent6"/>
-                </a:solidFill>
-                <a:effectLst/>
-                <a:uLnTx/>
-                <a:uFillTx/>
-                <a:latin typeface="EB Garamond"/>
-                <a:ea typeface="EB Garamond"/>
-                <a:sym typeface="EB Garamond"/>
-              </a:rPr>
-              <a:t>There are 1,859,826 tax-exempt organizations in the country.</a:t>
-            </a:r>
-            <a:endParaRPr kumimoji="0" lang="en-US" sz="1400" b="0" i="0" u="none" strike="noStrike" kern="0" cap="none" spc="0" normalizeH="0" baseline="0" noProof="0" dirty="0">
-              <a:ln>
-                <a:noFill/>
-              </a:ln>
-              <a:solidFill>
-                <a:srgbClr val="000000"/>
-              </a:solidFill>
-              <a:effectLst/>
-              <a:uLnTx/>
-              <a:uFillTx/>
-              <a:latin typeface="Arial"/>
-              <a:cs typeface="Arial"/>
-              <a:sym typeface="Arial"/>
+            <a:endParaRPr lang="en-US" sz="3000" dirty="0">
+              <a:latin typeface="EB Garamond" pitchFamily="2" charset="0"/>
+              <a:ea typeface="EB Garamond" pitchFamily="2" charset="0"/>
             </a:endParaRPr>
           </a:p>
           <a:p>
-            <a:pPr marL="0" marR="0" lvl="0" indent="0" algn="just" rtl="0">
-              <a:spcBef>
-                <a:spcPts val="1200"/>
-              </a:spcBef>
-              <a:spcAft>
-                <a:spcPts val="0"/>
-              </a:spcAft>
-              <a:buNone/>
-            </a:pPr>
-            <a:r>
-              <a:rPr lang="en-US" sz="3000" b="1" dirty="0">
-                <a:latin typeface="EB Garamond"/>
-                <a:ea typeface="EB Garamond"/>
-                <a:cs typeface="EB Garamond"/>
-                <a:sym typeface="EB Garamond"/>
-              </a:rPr>
-              <a:t>Language and Impact</a:t>
-            </a:r>
             <a:r>
               <a:rPr lang="en-US" sz="3000" dirty="0">
-                <a:latin typeface="EB Garamond"/>
-                <a:ea typeface="EB Garamond"/>
-                <a:cs typeface="EB Garamond"/>
-                <a:sym typeface="EB Garamond"/>
+                <a:latin typeface="EB Garamond" pitchFamily="2" charset="0"/>
+                <a:ea typeface="EB Garamond" pitchFamily="2" charset="0"/>
               </a:rPr>
-              <a:t>:</a:t>
+              <a:t>Despite this, the causal link between wildfire shocks and conflict remains understudied. Existing research documents co-occurrence of fires and social unrest, but stops short of establishing causality — leaving a critical gap for policymakers designing climate adaptation and conflict-prevention strategies. This study addresses that gap by exploiting spatiotemporal variation in wildfire exposure across Indonesian districts to estimate its effect on conflict probability and intensity, using ACLED conflict data and satellite-derived fire records.</a:t>
             </a:r>
-            <a:endParaRPr lang="en-US" sz="3000" b="1" i="0" u="none" strike="noStrike" cap="none" dirty="0">
-              <a:solidFill>
-                <a:schemeClr val="accent6"/>
-              </a:solidFill>
-              <a:latin typeface="EB Garamond"/>
-              <a:ea typeface="EB Garamond"/>
-              <a:cs typeface="EB Garamond"/>
-              <a:sym typeface="EB Garamond"/>
-            </a:endParaRPr>
-          </a:p>
-          <a:p>
-            <a:pPr marL="457200" marR="0" lvl="0" indent="-457200" algn="just" defTabSz="914400" rtl="0" eaLnBrk="1" fontAlgn="auto" latinLnBrk="0" hangingPunct="1">
-              <a:lnSpc>
-                <a:spcPct val="100000"/>
-              </a:lnSpc>
-              <a:spcBef>
-                <a:spcPts val="0"/>
-              </a:spcBef>
-              <a:spcAft>
-                <a:spcPts val="0"/>
-              </a:spcAft>
-              <a:buClr>
-                <a:srgbClr val="000000"/>
-              </a:buClr>
-              <a:buSzPts val="3000"/>
-              <a:buFont typeface="Arial"/>
-              <a:buChar char="•"/>
-              <a:tabLst/>
-              <a:defRPr/>
-            </a:pPr>
-            <a:r>
-              <a:rPr lang="en-US" sz="3000" dirty="0">
-                <a:solidFill>
-                  <a:schemeClr val="accent6"/>
-                </a:solidFill>
-                <a:latin typeface="EB Garamond"/>
-                <a:ea typeface="EB Garamond"/>
-                <a:cs typeface="EB Garamond"/>
-                <a:sym typeface="EB Garamond"/>
-              </a:rPr>
-              <a:t>Prior research suggests that mission statement language correlates with economic and organizational performance (2, 3).</a:t>
-            </a:r>
-          </a:p>
-          <a:p>
-            <a:pPr marR="0" lvl="0" algn="just" rtl="0">
-              <a:spcBef>
-                <a:spcPts val="0"/>
-              </a:spcBef>
-              <a:spcAft>
-                <a:spcPts val="0"/>
-              </a:spcAft>
-              <a:buClr>
-                <a:schemeClr val="accent6"/>
-              </a:buClr>
-              <a:buSzPts val="3000"/>
-            </a:pPr>
-            <a:endParaRPr lang="en-US" sz="3000" b="1" dirty="0">
-              <a:solidFill>
-                <a:schemeClr val="accent6"/>
-              </a:solidFill>
-              <a:latin typeface="EB Garamond"/>
-              <a:ea typeface="EB Garamond"/>
-              <a:cs typeface="EB Garamond"/>
-              <a:sym typeface="EB Garamond"/>
-            </a:endParaRPr>
-          </a:p>
-          <a:p>
-            <a:pPr marL="457200" marR="0" lvl="0" indent="-457200" algn="just" rtl="0">
-              <a:spcBef>
-                <a:spcPts val="0"/>
-              </a:spcBef>
-              <a:spcAft>
-                <a:spcPts val="0"/>
-              </a:spcAft>
-              <a:buClr>
-                <a:schemeClr val="accent6"/>
-              </a:buClr>
-              <a:buSzPts val="3000"/>
-              <a:buFont typeface="Arial"/>
-              <a:buChar char="•"/>
-            </a:pPr>
-            <a:endParaRPr lang="en-US" sz="3000" b="0" i="0" u="none" strike="noStrike" cap="none" dirty="0">
-              <a:solidFill>
-                <a:schemeClr val="accent6"/>
-              </a:solidFill>
-              <a:latin typeface="EB Garamond"/>
-              <a:ea typeface="EB Garamond"/>
-              <a:cs typeface="EB Garamond"/>
-              <a:sym typeface="EB Garamond"/>
-            </a:endParaRPr>
           </a:p>
         </p:txBody>
       </p:sp>
@@ -12082,8 +11672,8 @@
         </p:nvSpPr>
         <p:spPr>
           <a:xfrm>
-            <a:off x="32820640" y="22375533"/>
-            <a:ext cx="9885343" cy="3754834"/>
+            <a:off x="32820640" y="17271908"/>
+            <a:ext cx="9885343" cy="7478930"/>
           </a:xfrm>
           <a:prstGeom prst="rect">
             <a:avLst/>
@@ -12099,28 +11689,84 @@
           </a:bodyPr>
           <a:lstStyle/>
           <a:p>
-            <a:pPr marL="0" marR="0" lvl="0" indent="0" algn="just" rtl="0">
-              <a:spcBef>
-                <a:spcPts val="0"/>
-              </a:spcBef>
-              <a:spcAft>
-                <a:spcPts val="0"/>
-              </a:spcAft>
-              <a:buNone/>
+            <a:pPr marL="285750" indent="-285750">
+              <a:buFont typeface="Arial" panose="020B0604020202020204" pitchFamily="34" charset="0"/>
+              <a:buChar char="•"/>
             </a:pPr>
             <a:r>
+              <a:rPr lang="en-US" sz="3000" b="1" dirty="0">
+                <a:latin typeface="EB Garamond" pitchFamily="2" charset="0"/>
+                <a:ea typeface="EB Garamond" pitchFamily="2" charset="0"/>
+              </a:rPr>
+              <a:t>Instrumental Variable Approach</a:t>
+            </a:r>
+            <a:r>
               <a:rPr lang="en-US" sz="3000" dirty="0">
-                <a:solidFill>
-                  <a:schemeClr val="accent6"/>
-                </a:solidFill>
-                <a:latin typeface="EB Garamond"/>
-                <a:ea typeface="EB Garamond"/>
-                <a:cs typeface="EB Garamond"/>
-                <a:sym typeface="EB Garamond"/>
+                <a:latin typeface="EB Garamond" pitchFamily="2" charset="0"/>
+                <a:ea typeface="EB Garamond" pitchFamily="2" charset="0"/>
               </a:rPr>
-              <a:t>The next steps are:</a:t>
+              <a:t> — Implement wind patterns as an instrument for wildfire exposure, exploiting exogenous variation in fire smoke dispersal to strengthen causal identification</a:t>
             </a:r>
-            <a:endParaRPr dirty="0"/>
+          </a:p>
+          <a:p>
+            <a:pPr marL="285750" indent="-285750">
+              <a:buFont typeface="Arial" panose="020B0604020202020204" pitchFamily="34" charset="0"/>
+              <a:buChar char="•"/>
+            </a:pPr>
+            <a:r>
+              <a:rPr lang="en-US" sz="3000" b="1" dirty="0">
+                <a:latin typeface="EB Garamond" pitchFamily="2" charset="0"/>
+                <a:ea typeface="EB Garamond" pitchFamily="2" charset="0"/>
+              </a:rPr>
+              <a:t>Mechanism identification</a:t>
+            </a:r>
+            <a:r>
+              <a:rPr lang="en-US" sz="3000" dirty="0">
+                <a:latin typeface="EB Garamond" pitchFamily="2" charset="0"/>
+                <a:ea typeface="EB Garamond" pitchFamily="2" charset="0"/>
+              </a:rPr>
+              <a:t> — Subsequent analysis will disentangle whether conflict is driven primarily by crop loss, displacement, or competition over remaining resources</a:t>
+            </a:r>
+          </a:p>
+          <a:p>
+            <a:pPr marL="285750" indent="-285750">
+              <a:buFont typeface="Arial" panose="020B0604020202020204" pitchFamily="34" charset="0"/>
+              <a:buChar char="•"/>
+            </a:pPr>
+            <a:r>
+              <a:rPr lang="en-US" sz="3000" b="1" dirty="0">
+                <a:latin typeface="EB Garamond" pitchFamily="2" charset="0"/>
+                <a:ea typeface="EB Garamond" pitchFamily="2" charset="0"/>
+              </a:rPr>
+              <a:t>Heterogeneity by land tenure</a:t>
+            </a:r>
+            <a:r>
+              <a:rPr lang="en-US" sz="3000" dirty="0">
+                <a:latin typeface="EB Garamond" pitchFamily="2" charset="0"/>
+                <a:ea typeface="EB Garamond" pitchFamily="2" charset="0"/>
+              </a:rPr>
+              <a:t> — Examining conflict responses across formal vs. informal land tenure regions, particularly in palm oil and pulpwood concession areas, will clarify the role of institutional context</a:t>
+            </a:r>
+          </a:p>
+          <a:p>
+            <a:pPr marL="285750" indent="-285750">
+              <a:buFont typeface="Arial" panose="020B0604020202020204" pitchFamily="34" charset="0"/>
+              <a:buChar char="•"/>
+            </a:pPr>
+            <a:r>
+              <a:rPr lang="en-US" sz="3000" b="1" dirty="0">
+                <a:latin typeface="EB Garamond" pitchFamily="2" charset="0"/>
+                <a:ea typeface="EB Garamond" pitchFamily="2" charset="0"/>
+              </a:rPr>
+              <a:t>Policy evaluation</a:t>
+            </a:r>
+            <a:r>
+              <a:rPr lang="en-US" sz="3000" dirty="0">
+                <a:latin typeface="EB Garamond" pitchFamily="2" charset="0"/>
+                <a:ea typeface="EB Garamond" pitchFamily="2" charset="0"/>
+              </a:rPr>
+              <a:t> — Future research will exploit Indonesia's Peatland Restoration Agency (BRG) interventions as natural experiments to test whether fire-prevention policies also reduce conflict risk</a:t>
+            </a:r>
           </a:p>
           <a:p>
             <a:pPr marL="457200" marR="0" lvl="0" indent="-457200" algn="just" rtl="0">
@@ -12137,137 +11783,10 @@
               <a:buFont typeface="Arial"/>
               <a:buChar char="•"/>
             </a:pPr>
-            <a:r>
-              <a:rPr lang="en-US" sz="3000" dirty="0">
-                <a:solidFill>
-                  <a:schemeClr val="accent6"/>
-                </a:solidFill>
-                <a:latin typeface="EB Garamond"/>
-                <a:ea typeface="EB Garamond"/>
-                <a:cs typeface="EB Garamond"/>
-                <a:sym typeface="EB Garamond"/>
-              </a:rPr>
-              <a:t>Generate and process data from the United Kingdom, Australia, and Canada.</a:t>
-            </a:r>
-            <a:endParaRPr dirty="0"/>
-          </a:p>
-          <a:p>
-            <a:pPr marL="457200" marR="0" lvl="0" indent="-457200" algn="just" rtl="0">
-              <a:spcBef>
-                <a:spcPts val="0"/>
-              </a:spcBef>
-              <a:spcAft>
-                <a:spcPts val="0"/>
-              </a:spcAft>
-              <a:buClr>
-                <a:schemeClr val="accent6"/>
-              </a:buClr>
-              <a:buSzPts val="3000"/>
-              <a:buFont typeface="Arial"/>
-              <a:buChar char="•"/>
-            </a:pPr>
-            <a:r>
-              <a:rPr lang="en-US" sz="3000" dirty="0">
-                <a:solidFill>
-                  <a:schemeClr val="accent6"/>
-                </a:solidFill>
-                <a:latin typeface="EB Garamond"/>
-                <a:ea typeface="EB Garamond"/>
-                <a:cs typeface="EB Garamond"/>
-                <a:sym typeface="EB Garamond"/>
-              </a:rPr>
-              <a:t>Analyze the data for linguistic features and trends.</a:t>
-            </a:r>
-          </a:p>
-          <a:p>
-            <a:pPr marL="457200" marR="0" lvl="0" indent="-457200" algn="just" rtl="0">
-              <a:spcBef>
-                <a:spcPts val="0"/>
-              </a:spcBef>
-              <a:spcAft>
-                <a:spcPts val="0"/>
-              </a:spcAft>
-              <a:buClr>
-                <a:schemeClr val="accent6"/>
-              </a:buClr>
-              <a:buSzPts val="3000"/>
-              <a:buFont typeface="Arial"/>
-              <a:buChar char="•"/>
-            </a:pPr>
-            <a:r>
-              <a:rPr lang="en-US" sz="3000" dirty="0">
-                <a:solidFill>
-                  <a:schemeClr val="accent6"/>
-                </a:solidFill>
-                <a:latin typeface="EB Garamond"/>
-                <a:ea typeface="EB Garamond"/>
-                <a:cs typeface="EB Garamond"/>
-                <a:sym typeface="EB Garamond"/>
-              </a:rPr>
-              <a:t>Train ML model on training data to estimate revenue of tax-exempt organization given mission statement and asset code.</a:t>
-            </a:r>
-          </a:p>
-          <a:p>
-            <a:pPr marL="457200" marR="0" lvl="0" indent="-457200" algn="just" rtl="0">
-              <a:spcBef>
-                <a:spcPts val="0"/>
-              </a:spcBef>
-              <a:spcAft>
-                <a:spcPts val="0"/>
-              </a:spcAft>
-              <a:buClr>
-                <a:schemeClr val="accent6"/>
-              </a:buClr>
-              <a:buSzPts val="3000"/>
-              <a:buFont typeface="Arial"/>
-              <a:buChar char="•"/>
-            </a:pPr>
-            <a:r>
-              <a:rPr lang="en-US" sz="3000" dirty="0">
-                <a:solidFill>
-                  <a:schemeClr val="accent6"/>
-                </a:solidFill>
-                <a:latin typeface="EB Garamond"/>
-                <a:ea typeface="EB Garamond"/>
-                <a:cs typeface="EB Garamond"/>
-                <a:sym typeface="EB Garamond"/>
-              </a:rPr>
-              <a:t>Test ML on testing data.</a:t>
-            </a:r>
-          </a:p>
-          <a:p>
-            <a:pPr marL="457200" marR="0" lvl="0" indent="-457200" algn="just" rtl="0">
-              <a:spcBef>
-                <a:spcPts val="0"/>
-              </a:spcBef>
-              <a:spcAft>
-                <a:spcPts val="0"/>
-              </a:spcAft>
-              <a:buClr>
-                <a:schemeClr val="accent6"/>
-              </a:buClr>
-              <a:buSzPts val="3000"/>
-              <a:buFont typeface="Arial"/>
-              <a:buChar char="•"/>
-            </a:pPr>
-            <a:endParaRPr dirty="0"/>
-          </a:p>
-          <a:p>
-            <a:pPr marL="457200" marR="0" lvl="0" indent="-457200" algn="just" rtl="0">
-              <a:spcBef>
-                <a:spcPts val="0"/>
-              </a:spcBef>
-              <a:spcAft>
-                <a:spcPts val="0"/>
-              </a:spcAft>
-              <a:buClr>
-                <a:schemeClr val="accent6"/>
-              </a:buClr>
-              <a:buSzPts val="3000"/>
-              <a:buFont typeface="Arial"/>
-              <a:buChar char="•"/>
-            </a:pPr>
-            <a:endParaRPr dirty="0"/>
+            <a:endParaRPr sz="3000" dirty="0">
+              <a:latin typeface="EB Garamond" pitchFamily="2" charset="0"/>
+              <a:ea typeface="EB Garamond" pitchFamily="2" charset="0"/>
+            </a:endParaRPr>
           </a:p>
         </p:txBody>
       </p:sp>
@@ -12279,7 +11798,7 @@
         </p:nvSpPr>
         <p:spPr>
           <a:xfrm>
-            <a:off x="7013892" y="965916"/>
+            <a:off x="7013892" y="1270716"/>
             <a:ext cx="28948613" cy="4339609"/>
           </a:xfrm>
           <a:prstGeom prst="rect">
@@ -12310,8 +11829,8 @@
                 <a:solidFill>
                   <a:schemeClr val="lt1"/>
                 </a:solidFill>
-                <a:latin typeface="Helvetica Neue"/>
-                <a:ea typeface="Helvetica Neue"/>
+                <a:latin typeface="EB Garamond" pitchFamily="2" charset="0"/>
+                <a:ea typeface="EB Garamond" pitchFamily="2" charset="0"/>
                 <a:cs typeface="Helvetica Neue"/>
                 <a:sym typeface="Helvetica Neue"/>
               </a:rPr>
@@ -12333,14 +11852,17 @@
                 <a:solidFill>
                   <a:schemeClr val="lt1"/>
                 </a:solidFill>
-                <a:latin typeface="Helvetica Neue"/>
-                <a:ea typeface="Helvetica Neue"/>
+                <a:latin typeface="EB Garamond" pitchFamily="2" charset="0"/>
+                <a:ea typeface="EB Garamond" pitchFamily="2" charset="0"/>
                 <a:cs typeface="Helvetica Neue"/>
                 <a:sym typeface="Helvetica Neue"/>
               </a:rPr>
               <a:t>Hariaksha Gunda*, Dr. Michael Price</a:t>
             </a:r>
-            <a:endParaRPr lang="en-US" sz="6000" dirty="0"/>
+            <a:endParaRPr lang="en-US" sz="6000" dirty="0">
+              <a:latin typeface="EB Garamond" pitchFamily="2" charset="0"/>
+              <a:ea typeface="EB Garamond" pitchFamily="2" charset="0"/>
+            </a:endParaRPr>
           </a:p>
           <a:p>
             <a:pPr marL="0" marR="0" lvl="0" indent="0" algn="ctr" rtl="0">
@@ -12357,8 +11879,8 @@
                 <a:solidFill>
                   <a:schemeClr val="lt1"/>
                 </a:solidFill>
-                <a:latin typeface="Helvetica Neue"/>
-                <a:ea typeface="Helvetica Neue"/>
+                <a:latin typeface="EB Garamond" pitchFamily="2" charset="0"/>
+                <a:ea typeface="EB Garamond" pitchFamily="2" charset="0"/>
                 <a:cs typeface="Helvetica Neue"/>
                 <a:sym typeface="Helvetica Neue"/>
               </a:rPr>
@@ -12368,8 +11890,8 @@
               <a:solidFill>
                 <a:schemeClr val="lt1"/>
               </a:solidFill>
-              <a:latin typeface="Helvetica Neue"/>
-              <a:ea typeface="Helvetica Neue"/>
+              <a:latin typeface="EB Garamond" pitchFamily="2" charset="0"/>
+              <a:ea typeface="EB Garamond" pitchFamily="2" charset="0"/>
               <a:cs typeface="Helvetica Neue"/>
               <a:sym typeface="Helvetica Neue"/>
             </a:endParaRPr>
@@ -12482,121 +12004,9 @@
                 <a:cs typeface="Verdana"/>
                 <a:sym typeface="Verdana"/>
               </a:rPr>
-              <a:t>ABSTRACT</a:t>
+              <a:t>QUESTION AND SIGNIFICANCE</a:t>
             </a:r>
             <a:endParaRPr dirty="0"/>
-          </a:p>
-        </p:txBody>
-      </p:sp>
-      <p:sp>
-        <p:nvSpPr>
-          <p:cNvPr id="98" name="Google Shape;98;p1"/>
-          <p:cNvSpPr/>
-          <p:nvPr/>
-        </p:nvSpPr>
-        <p:spPr>
-          <a:xfrm>
-            <a:off x="861777" y="16926453"/>
-            <a:ext cx="10241280" cy="914400"/>
-          </a:xfrm>
-          <a:prstGeom prst="rect">
-            <a:avLst/>
-          </a:prstGeom>
-          <a:solidFill>
-            <a:srgbClr val="9C2334"/>
-          </a:solidFill>
-          <a:ln>
-            <a:noFill/>
-          </a:ln>
-          <a:effectLst>
-            <a:outerShdw blurRad="50800" dist="38100" dir="5400000" algn="t" rotWithShape="0">
-              <a:srgbClr val="000000">
-                <a:alpha val="40000"/>
-              </a:srgbClr>
-            </a:outerShdw>
-          </a:effectLst>
-        </p:spPr>
-        <p:txBody>
-          <a:bodyPr spcFirstLastPara="1" wrap="square" lIns="91425" tIns="45700" rIns="91425" bIns="45700" anchor="ctr" anchorCtr="0">
-            <a:noAutofit/>
-          </a:bodyPr>
-          <a:lstStyle/>
-          <a:p>
-            <a:pPr marL="0" marR="0" lvl="0" indent="0" algn="ctr" rtl="0">
-              <a:spcBef>
-                <a:spcPts val="0"/>
-              </a:spcBef>
-              <a:spcAft>
-                <a:spcPts val="0"/>
-              </a:spcAft>
-              <a:buNone/>
-            </a:pPr>
-            <a:endParaRPr sz="8600">
-              <a:solidFill>
-                <a:schemeClr val="lt1"/>
-              </a:solidFill>
-              <a:latin typeface="Corbel"/>
-              <a:ea typeface="Corbel"/>
-              <a:cs typeface="Corbel"/>
-              <a:sym typeface="Corbel"/>
-            </a:endParaRPr>
-          </a:p>
-        </p:txBody>
-      </p:sp>
-      <p:sp>
-        <p:nvSpPr>
-          <p:cNvPr id="99" name="Google Shape;99;p1"/>
-          <p:cNvSpPr txBox="1"/>
-          <p:nvPr/>
-        </p:nvSpPr>
-        <p:spPr>
-          <a:xfrm>
-            <a:off x="1361840" y="16954193"/>
-            <a:ext cx="9083675" cy="769938"/>
-          </a:xfrm>
-          <a:prstGeom prst="rect">
-            <a:avLst/>
-          </a:prstGeom>
-          <a:noFill/>
-          <a:ln>
-            <a:noFill/>
-          </a:ln>
-          <a:effectLst>
-            <a:outerShdw blurRad="40000" dist="20000" dir="5400000" rotWithShape="0">
-              <a:srgbClr val="000000">
-                <a:alpha val="37647"/>
-              </a:srgbClr>
-            </a:outerShdw>
-          </a:effectLst>
-        </p:spPr>
-        <p:txBody>
-          <a:bodyPr spcFirstLastPara="1" wrap="square" lIns="91425" tIns="45700" rIns="91425" bIns="45700" anchor="t" anchorCtr="0">
-            <a:spAutoFit/>
-          </a:bodyPr>
-          <a:lstStyle/>
-          <a:p>
-            <a:pPr marL="0" marR="0" lvl="0" indent="0" algn="ctr" rtl="0">
-              <a:spcBef>
-                <a:spcPts val="0"/>
-              </a:spcBef>
-              <a:spcAft>
-                <a:spcPts val="0"/>
-              </a:spcAft>
-              <a:buNone/>
-            </a:pPr>
-            <a:r>
-              <a:rPr lang="en-US" sz="4400">
-                <a:solidFill>
-                  <a:schemeClr val="lt1"/>
-                </a:solidFill>
-                <a:latin typeface="Verdana"/>
-                <a:ea typeface="Verdana"/>
-                <a:cs typeface="Verdana"/>
-                <a:sym typeface="Verdana"/>
-              </a:rPr>
-              <a:t>BACKGROUND</a:t>
-            </a:r>
-            <a:endParaRPr/>
           </a:p>
         </p:txBody>
       </p:sp>
@@ -12697,7 +12107,7 @@
               <a:buNone/>
             </a:pPr>
             <a:r>
-              <a:rPr lang="en-US" sz="4400" dirty="0">
+              <a:rPr lang="en-US" sz="4400">
                 <a:solidFill>
                   <a:schemeClr val="lt1"/>
                 </a:solidFill>
@@ -12706,7 +12116,7 @@
                 <a:cs typeface="Verdana"/>
                 <a:sym typeface="Verdana"/>
               </a:rPr>
-              <a:t>METHODOLOGY</a:t>
+              <a:t>DATA AND METHODS</a:t>
             </a:r>
             <a:endParaRPr dirty="0"/>
           </a:p>
@@ -12818,7 +12228,7 @@
                 <a:cs typeface="Verdana"/>
                 <a:sym typeface="Verdana"/>
               </a:rPr>
-              <a:t>FORMULAS</a:t>
+              <a:t>STUDY AREA</a:t>
             </a:r>
             <a:endParaRPr dirty="0"/>
           </a:p>
@@ -12832,7 +12242,7 @@
         </p:nvSpPr>
         <p:spPr>
           <a:xfrm>
-            <a:off x="32613171" y="21119165"/>
+            <a:off x="32613171" y="16100600"/>
             <a:ext cx="10241280" cy="914400"/>
           </a:xfrm>
           <a:prstGeom prst="rect">
@@ -12887,7 +12297,7 @@
         </p:nvSpPr>
         <p:spPr>
           <a:xfrm>
-            <a:off x="32959728" y="21183094"/>
+            <a:off x="32959728" y="16164529"/>
             <a:ext cx="9607873" cy="769441"/>
           </a:xfrm>
           <a:prstGeom prst="rect">
@@ -12971,7 +12381,7 @@
         </p:nvSpPr>
         <p:spPr>
           <a:xfrm>
-            <a:off x="32612708" y="26095085"/>
+            <a:off x="32612708" y="25648520"/>
             <a:ext cx="10241280" cy="914400"/>
           </a:xfrm>
           <a:prstGeom prst="rect">
@@ -13026,7 +12436,7 @@
         </p:nvSpPr>
         <p:spPr>
           <a:xfrm>
-            <a:off x="32613172" y="25998247"/>
+            <a:off x="32613172" y="25551682"/>
             <a:ext cx="10236053" cy="914400"/>
           </a:xfrm>
           <a:prstGeom prst="rect">
@@ -13097,765 +12507,16 @@
           </a:ln>
         </p:spPr>
       </p:pic>
-      <mc:AlternateContent xmlns:mc="http://schemas.openxmlformats.org/markup-compatibility/2006" xmlns:a14="http://schemas.microsoft.com/office/drawing/2010/main">
-        <mc:Choice Requires="a14">
-          <p:sp>
-            <p:nvSpPr>
-              <p:cNvPr id="110" name="Google Shape;110;p1"/>
-              <p:cNvSpPr/>
-              <p:nvPr/>
-            </p:nvSpPr>
-            <p:spPr>
-              <a:xfrm>
-                <a:off x="32796053" y="8848013"/>
-                <a:ext cx="9502898" cy="5770963"/>
-              </a:xfrm>
-              <a:prstGeom prst="rect">
-                <a:avLst/>
-              </a:prstGeom>
-              <a:noFill/>
-              <a:ln>
-                <a:noFill/>
-              </a:ln>
-            </p:spPr>
-            <p:txBody>
-              <a:bodyPr spcFirstLastPara="1" wrap="square" lIns="91425" tIns="45700" rIns="91425" bIns="45700" anchor="t" anchorCtr="0">
-                <a:spAutoFit/>
-              </a:bodyPr>
-              <a:lstStyle/>
-              <a:p>
-                <a:pPr marL="0" marR="0" lvl="0" indent="0" algn="just" rtl="0">
-                  <a:spcBef>
-                    <a:spcPts val="0"/>
-                  </a:spcBef>
-                  <a:spcAft>
-                    <a:spcPts val="0"/>
-                  </a:spcAft>
-                  <a:buNone/>
-                </a:pPr>
-                <a:r>
-                  <a:rPr lang="en-US" sz="3000" b="1" dirty="0">
-                    <a:solidFill>
-                      <a:schemeClr val="accent6"/>
-                    </a:solidFill>
-                    <a:latin typeface="EB Garamond"/>
-                    <a:ea typeface="EB Garamond"/>
-                    <a:cs typeface="EB Garamond"/>
-                    <a:sym typeface="EB Garamond"/>
-                  </a:rPr>
-                  <a:t>Flesch Reading Ease Score:</a:t>
-                </a:r>
-              </a:p>
-              <a:p>
-                <a:pPr marL="0" marR="0" lvl="0" indent="0" algn="just" rtl="0">
-                  <a:spcBef>
-                    <a:spcPts val="0"/>
-                  </a:spcBef>
-                  <a:spcAft>
-                    <a:spcPts val="0"/>
-                  </a:spcAft>
-                  <a:buNone/>
-                </a:pPr>
-                <a:endParaRPr lang="en-US" sz="3000" dirty="0">
-                  <a:solidFill>
-                    <a:schemeClr val="accent6"/>
-                  </a:solidFill>
-                  <a:latin typeface="EB Garamond"/>
-                  <a:ea typeface="EB Garamond"/>
-                  <a:cs typeface="EB Garamond"/>
-                  <a:sym typeface="EB Garamond"/>
-                </a:endParaRPr>
-              </a:p>
-              <a:p>
-                <a:pPr lvl="0" algn="just"/>
-                <a14:m>
-                  <m:oMathPara xmlns:m="http://schemas.openxmlformats.org/officeDocument/2006/math">
-                    <m:oMathParaPr>
-                      <m:jc m:val="centerGroup"/>
-                    </m:oMathParaPr>
-                    <m:oMath xmlns:m="http://schemas.openxmlformats.org/officeDocument/2006/math">
-                      <m:r>
-                        <a:rPr lang="en-US" sz="3000" b="0" i="1" smtClean="0">
-                          <a:solidFill>
-                            <a:schemeClr val="accent6"/>
-                          </a:solidFill>
-                          <a:latin typeface="Cambria Math" panose="02040503050406030204" pitchFamily="18" charset="0"/>
-                          <a:ea typeface="EB Garamond"/>
-                          <a:cs typeface="EB Garamond"/>
-                          <a:sym typeface="EB Garamond"/>
-                        </a:rPr>
-                        <m:t>𝑆𝑐𝑜𝑟𝑒</m:t>
-                      </m:r>
-                      <m:r>
-                        <a:rPr lang="en-US" sz="3000" b="0" i="1" smtClean="0">
-                          <a:solidFill>
-                            <a:schemeClr val="accent6"/>
-                          </a:solidFill>
-                          <a:latin typeface="Cambria Math" panose="02040503050406030204" pitchFamily="18" charset="0"/>
-                          <a:ea typeface="EB Garamond"/>
-                          <a:cs typeface="EB Garamond"/>
-                          <a:sym typeface="EB Garamond"/>
-                        </a:rPr>
-                        <m:t>=1.015</m:t>
-                      </m:r>
-                      <m:d>
-                        <m:dPr>
-                          <m:ctrlPr>
-                            <a:rPr lang="en-US" sz="3000" b="0" i="1" smtClean="0">
-                              <a:solidFill>
-                                <a:schemeClr val="accent6"/>
-                              </a:solidFill>
-                              <a:latin typeface="Cambria Math" panose="02040503050406030204" pitchFamily="18" charset="0"/>
-                              <a:ea typeface="EB Garamond"/>
-                              <a:cs typeface="EB Garamond"/>
-                              <a:sym typeface="EB Garamond"/>
-                            </a:rPr>
-                          </m:ctrlPr>
-                        </m:dPr>
-                        <m:e>
-                          <m:f>
-                            <m:fPr>
-                              <m:ctrlPr>
-                                <a:rPr lang="en-US" sz="3000" b="0" i="1" smtClean="0">
-                                  <a:solidFill>
-                                    <a:schemeClr val="accent6"/>
-                                  </a:solidFill>
-                                  <a:latin typeface="Cambria Math" panose="02040503050406030204" pitchFamily="18" charset="0"/>
-                                  <a:ea typeface="EB Garamond"/>
-                                  <a:cs typeface="EB Garamond"/>
-                                  <a:sym typeface="EB Garamond"/>
-                                </a:rPr>
-                              </m:ctrlPr>
-                            </m:fPr>
-                            <m:num>
-                              <m:r>
-                                <a:rPr lang="en-US" sz="3000" b="0" i="1" smtClean="0">
-                                  <a:solidFill>
-                                    <a:schemeClr val="accent6"/>
-                                  </a:solidFill>
-                                  <a:latin typeface="Cambria Math" panose="02040503050406030204" pitchFamily="18" charset="0"/>
-                                  <a:ea typeface="EB Garamond"/>
-                                  <a:cs typeface="EB Garamond"/>
-                                  <a:sym typeface="EB Garamond"/>
-                                </a:rPr>
-                                <m:t>𝑡𝑜𝑡𝑎𝑙</m:t>
-                              </m:r>
-                              <m:r>
-                                <a:rPr lang="en-US" sz="3000" b="0" i="1" smtClean="0">
-                                  <a:solidFill>
-                                    <a:schemeClr val="accent6"/>
-                                  </a:solidFill>
-                                  <a:latin typeface="Cambria Math" panose="02040503050406030204" pitchFamily="18" charset="0"/>
-                                  <a:ea typeface="EB Garamond"/>
-                                  <a:cs typeface="EB Garamond"/>
-                                  <a:sym typeface="EB Garamond"/>
-                                </a:rPr>
-                                <m:t> </m:t>
-                              </m:r>
-                              <m:r>
-                                <a:rPr lang="en-US" sz="3000" b="0" i="1" smtClean="0">
-                                  <a:solidFill>
-                                    <a:schemeClr val="accent6"/>
-                                  </a:solidFill>
-                                  <a:latin typeface="Cambria Math" panose="02040503050406030204" pitchFamily="18" charset="0"/>
-                                  <a:ea typeface="EB Garamond"/>
-                                  <a:cs typeface="EB Garamond"/>
-                                  <a:sym typeface="EB Garamond"/>
-                                </a:rPr>
-                                <m:t>𝑤𝑜𝑟𝑑𝑠</m:t>
-                              </m:r>
-                            </m:num>
-                            <m:den>
-                              <m:r>
-                                <a:rPr lang="en-US" sz="3000" b="0" i="1" smtClean="0">
-                                  <a:solidFill>
-                                    <a:schemeClr val="accent6"/>
-                                  </a:solidFill>
-                                  <a:latin typeface="Cambria Math" panose="02040503050406030204" pitchFamily="18" charset="0"/>
-                                  <a:ea typeface="EB Garamond"/>
-                                  <a:cs typeface="EB Garamond"/>
-                                  <a:sym typeface="EB Garamond"/>
-                                </a:rPr>
-                                <m:t>𝑡𝑜𝑡𝑎𝑙</m:t>
-                              </m:r>
-                              <m:r>
-                                <a:rPr lang="en-US" sz="3000" b="0" i="1" smtClean="0">
-                                  <a:solidFill>
-                                    <a:schemeClr val="accent6"/>
-                                  </a:solidFill>
-                                  <a:latin typeface="Cambria Math" panose="02040503050406030204" pitchFamily="18" charset="0"/>
-                                  <a:ea typeface="EB Garamond"/>
-                                  <a:cs typeface="EB Garamond"/>
-                                  <a:sym typeface="EB Garamond"/>
-                                </a:rPr>
-                                <m:t> </m:t>
-                              </m:r>
-                              <m:r>
-                                <a:rPr lang="en-US" sz="3000" b="0" i="1" smtClean="0">
-                                  <a:solidFill>
-                                    <a:schemeClr val="accent6"/>
-                                  </a:solidFill>
-                                  <a:latin typeface="Cambria Math" panose="02040503050406030204" pitchFamily="18" charset="0"/>
-                                  <a:ea typeface="EB Garamond"/>
-                                  <a:cs typeface="EB Garamond"/>
-                                  <a:sym typeface="EB Garamond"/>
-                                </a:rPr>
-                                <m:t>𝑠𝑒𝑛𝑡𝑒𝑛𝑐𝑒𝑠</m:t>
-                              </m:r>
-                            </m:den>
-                          </m:f>
-                        </m:e>
-                      </m:d>
-                      <m:r>
-                        <a:rPr lang="en-US" sz="3000" b="0" i="1" smtClean="0">
-                          <a:solidFill>
-                            <a:schemeClr val="accent6"/>
-                          </a:solidFill>
-                          <a:latin typeface="Cambria Math" panose="02040503050406030204" pitchFamily="18" charset="0"/>
-                          <a:ea typeface="EB Garamond"/>
-                          <a:cs typeface="EB Garamond"/>
-                          <a:sym typeface="EB Garamond"/>
-                        </a:rPr>
-                        <m:t>−84.6(</m:t>
-                      </m:r>
-                      <m:f>
-                        <m:fPr>
-                          <m:ctrlPr>
-                            <a:rPr lang="en-US" sz="3000" b="0" i="1" smtClean="0">
-                              <a:solidFill>
-                                <a:schemeClr val="accent6"/>
-                              </a:solidFill>
-                              <a:latin typeface="Cambria Math" panose="02040503050406030204" pitchFamily="18" charset="0"/>
-                              <a:ea typeface="EB Garamond"/>
-                              <a:cs typeface="EB Garamond"/>
-                              <a:sym typeface="EB Garamond"/>
-                            </a:rPr>
-                          </m:ctrlPr>
-                        </m:fPr>
-                        <m:num>
-                          <m:r>
-                            <a:rPr lang="en-US" sz="3000" i="1">
-                              <a:solidFill>
-                                <a:schemeClr val="accent6"/>
-                              </a:solidFill>
-                              <a:latin typeface="Cambria Math" panose="02040503050406030204" pitchFamily="18" charset="0"/>
-                              <a:ea typeface="EB Garamond"/>
-                              <a:cs typeface="EB Garamond"/>
-                              <a:sym typeface="EB Garamond"/>
-                            </a:rPr>
-                            <m:t>𝑡𝑜𝑡𝑎𝑙</m:t>
-                          </m:r>
-                          <m:r>
-                            <a:rPr lang="en-US" sz="3000" b="0" i="1" smtClean="0">
-                              <a:solidFill>
-                                <a:schemeClr val="accent6"/>
-                              </a:solidFill>
-                              <a:latin typeface="Cambria Math" panose="02040503050406030204" pitchFamily="18" charset="0"/>
-                              <a:ea typeface="EB Garamond"/>
-                              <a:cs typeface="EB Garamond"/>
-                              <a:sym typeface="EB Garamond"/>
-                            </a:rPr>
-                            <m:t> </m:t>
-                          </m:r>
-                          <m:r>
-                            <a:rPr lang="en-US" sz="3000" b="0" i="1" smtClean="0">
-                              <a:solidFill>
-                                <a:schemeClr val="accent6"/>
-                              </a:solidFill>
-                              <a:latin typeface="Cambria Math" panose="02040503050406030204" pitchFamily="18" charset="0"/>
-                              <a:ea typeface="EB Garamond"/>
-                              <a:cs typeface="EB Garamond"/>
-                              <a:sym typeface="EB Garamond"/>
-                            </a:rPr>
-                            <m:t>𝑠𝑦𝑙𝑙𝑎𝑏𝑙𝑒𝑠</m:t>
-                          </m:r>
-                        </m:num>
-                        <m:den>
-                          <m:r>
-                            <a:rPr lang="en-US" sz="3000" b="0" i="1" smtClean="0">
-                              <a:solidFill>
-                                <a:schemeClr val="accent6"/>
-                              </a:solidFill>
-                              <a:latin typeface="Cambria Math" panose="02040503050406030204" pitchFamily="18" charset="0"/>
-                              <a:ea typeface="EB Garamond"/>
-                              <a:cs typeface="EB Garamond"/>
-                              <a:sym typeface="EB Garamond"/>
-                            </a:rPr>
-                            <m:t>𝑡𝑜𝑡𝑎𝑙</m:t>
-                          </m:r>
-                          <m:r>
-                            <a:rPr lang="en-US" sz="3000" b="0" i="1" smtClean="0">
-                              <a:solidFill>
-                                <a:schemeClr val="accent6"/>
-                              </a:solidFill>
-                              <a:latin typeface="Cambria Math" panose="02040503050406030204" pitchFamily="18" charset="0"/>
-                              <a:ea typeface="EB Garamond"/>
-                              <a:cs typeface="EB Garamond"/>
-                              <a:sym typeface="EB Garamond"/>
-                            </a:rPr>
-                            <m:t> </m:t>
-                          </m:r>
-                          <m:r>
-                            <a:rPr lang="en-US" sz="3000" b="0" i="1" smtClean="0">
-                              <a:solidFill>
-                                <a:schemeClr val="accent6"/>
-                              </a:solidFill>
-                              <a:latin typeface="Cambria Math" panose="02040503050406030204" pitchFamily="18" charset="0"/>
-                              <a:ea typeface="EB Garamond"/>
-                              <a:cs typeface="EB Garamond"/>
-                              <a:sym typeface="EB Garamond"/>
-                            </a:rPr>
-                            <m:t>𝑤𝑜𝑟𝑑𝑠</m:t>
-                          </m:r>
-                        </m:den>
-                      </m:f>
-                      <m:r>
-                        <a:rPr lang="en-US" sz="3000" b="0" i="1" smtClean="0">
-                          <a:solidFill>
-                            <a:schemeClr val="accent6"/>
-                          </a:solidFill>
-                          <a:latin typeface="Cambria Math" panose="02040503050406030204" pitchFamily="18" charset="0"/>
-                          <a:ea typeface="EB Garamond"/>
-                          <a:cs typeface="EB Garamond"/>
-                          <a:sym typeface="EB Garamond"/>
-                        </a:rPr>
-                        <m:t>)</m:t>
-                      </m:r>
-                    </m:oMath>
-                  </m:oMathPara>
-                </a14:m>
-                <a:endParaRPr lang="en-US" sz="3000" dirty="0">
-                  <a:solidFill>
-                    <a:schemeClr val="accent6"/>
-                  </a:solidFill>
-                  <a:latin typeface="EB Garamond"/>
-                  <a:ea typeface="EB Garamond"/>
-                  <a:cs typeface="EB Garamond"/>
-                  <a:sym typeface="EB Garamond"/>
-                </a:endParaRPr>
-              </a:p>
-              <a:p>
-                <a:pPr lvl="0" algn="just"/>
-                <a:endParaRPr lang="en-US" sz="3000" dirty="0">
-                  <a:solidFill>
-                    <a:schemeClr val="accent6"/>
-                  </a:solidFill>
-                  <a:latin typeface="EB Garamond"/>
-                  <a:ea typeface="EB Garamond"/>
-                  <a:cs typeface="EB Garamond"/>
-                  <a:sym typeface="EB Garamond"/>
-                </a:endParaRPr>
-              </a:p>
-              <a:p>
-                <a:pPr lvl="0" algn="just"/>
-                <a:r>
-                  <a:rPr lang="en-US" sz="3000" b="1" dirty="0">
-                    <a:solidFill>
-                      <a:schemeClr val="accent6"/>
-                    </a:solidFill>
-                    <a:latin typeface="EB Garamond"/>
-                    <a:ea typeface="EB Garamond"/>
-                    <a:cs typeface="EB Garamond"/>
-                    <a:sym typeface="EB Garamond"/>
-                  </a:rPr>
-                  <a:t>Hapax Richness Score:</a:t>
-                </a:r>
-              </a:p>
-              <a:p>
-                <a:pPr lvl="0" algn="just"/>
-                <a:endParaRPr lang="en-US" sz="3000" b="1" dirty="0">
-                  <a:solidFill>
-                    <a:schemeClr val="accent6"/>
-                  </a:solidFill>
-                  <a:latin typeface="EB Garamond"/>
-                  <a:ea typeface="EB Garamond"/>
-                  <a:cs typeface="EB Garamond"/>
-                  <a:sym typeface="EB Garamond"/>
-                </a:endParaRPr>
-              </a:p>
-              <a:p>
-                <a:pPr lvl="0" algn="just"/>
-                <a14:m>
-                  <m:oMathPara xmlns:m="http://schemas.openxmlformats.org/officeDocument/2006/math">
-                    <m:oMathParaPr>
-                      <m:jc m:val="centerGroup"/>
-                    </m:oMathParaPr>
-                    <m:oMath xmlns:m="http://schemas.openxmlformats.org/officeDocument/2006/math">
-                      <m:r>
-                        <a:rPr lang="en-US" sz="3000" b="0" i="1" smtClean="0">
-                          <a:solidFill>
-                            <a:schemeClr val="accent6"/>
-                          </a:solidFill>
-                          <a:latin typeface="Cambria Math" panose="02040503050406030204" pitchFamily="18" charset="0"/>
-                          <a:ea typeface="EB Garamond"/>
-                          <a:cs typeface="EB Garamond"/>
-                          <a:sym typeface="EB Garamond"/>
-                        </a:rPr>
-                        <m:t>𝑆𝑐𝑜𝑟𝑒</m:t>
-                      </m:r>
-                      <m:r>
-                        <a:rPr lang="en-US" sz="3000" b="0" i="1" smtClean="0">
-                          <a:solidFill>
-                            <a:schemeClr val="accent6"/>
-                          </a:solidFill>
-                          <a:latin typeface="Cambria Math" panose="02040503050406030204" pitchFamily="18" charset="0"/>
-                          <a:ea typeface="EB Garamond"/>
-                          <a:cs typeface="EB Garamond"/>
-                          <a:sym typeface="EB Garamond"/>
-                        </a:rPr>
-                        <m:t>=</m:t>
-                      </m:r>
-                      <m:f>
-                        <m:fPr>
-                          <m:ctrlPr>
-                            <a:rPr lang="en-US" sz="3000" b="0" i="1" smtClean="0">
-                              <a:solidFill>
-                                <a:schemeClr val="accent6"/>
-                              </a:solidFill>
-                              <a:latin typeface="Cambria Math" panose="02040503050406030204" pitchFamily="18" charset="0"/>
-                              <a:ea typeface="EB Garamond"/>
-                              <a:cs typeface="EB Garamond"/>
-                              <a:sym typeface="EB Garamond"/>
-                            </a:rPr>
-                          </m:ctrlPr>
-                        </m:fPr>
-                        <m:num>
-                          <m:r>
-                            <a:rPr lang="en-US" sz="3000" i="1">
-                              <a:solidFill>
-                                <a:schemeClr val="accent6"/>
-                              </a:solidFill>
-                              <a:latin typeface="Cambria Math" panose="02040503050406030204" pitchFamily="18" charset="0"/>
-                              <a:ea typeface="EB Garamond"/>
-                              <a:cs typeface="EB Garamond"/>
-                              <a:sym typeface="EB Garamond"/>
-                            </a:rPr>
-                            <m:t>𝑛𝑢𝑚𝑏𝑒𝑟</m:t>
-                          </m:r>
-                          <m:r>
-                            <a:rPr lang="en-US" sz="3000" i="1">
-                              <a:solidFill>
-                                <a:schemeClr val="accent6"/>
-                              </a:solidFill>
-                              <a:latin typeface="Cambria Math" panose="02040503050406030204" pitchFamily="18" charset="0"/>
-                              <a:ea typeface="EB Garamond"/>
-                              <a:cs typeface="EB Garamond"/>
-                              <a:sym typeface="EB Garamond"/>
-                            </a:rPr>
-                            <m:t> </m:t>
-                          </m:r>
-                          <m:r>
-                            <a:rPr lang="en-US" sz="3000" i="1">
-                              <a:solidFill>
-                                <a:schemeClr val="accent6"/>
-                              </a:solidFill>
-                              <a:latin typeface="Cambria Math" panose="02040503050406030204" pitchFamily="18" charset="0"/>
-                              <a:ea typeface="EB Garamond"/>
-                              <a:cs typeface="EB Garamond"/>
-                              <a:sym typeface="EB Garamond"/>
-                            </a:rPr>
-                            <m:t>𝑜𝑓</m:t>
-                          </m:r>
-                          <m:r>
-                            <a:rPr lang="en-US" sz="3000" i="1">
-                              <a:solidFill>
-                                <a:schemeClr val="accent6"/>
-                              </a:solidFill>
-                              <a:latin typeface="Cambria Math" panose="02040503050406030204" pitchFamily="18" charset="0"/>
-                              <a:ea typeface="EB Garamond"/>
-                              <a:cs typeface="EB Garamond"/>
-                              <a:sym typeface="EB Garamond"/>
-                            </a:rPr>
-                            <m:t> </m:t>
-                          </m:r>
-                          <m:r>
-                            <a:rPr lang="en-US" sz="3000" i="1">
-                              <a:solidFill>
-                                <a:schemeClr val="accent6"/>
-                              </a:solidFill>
-                              <a:latin typeface="Cambria Math" panose="02040503050406030204" pitchFamily="18" charset="0"/>
-                              <a:ea typeface="EB Garamond"/>
-                              <a:cs typeface="EB Garamond"/>
-                              <a:sym typeface="EB Garamond"/>
-                            </a:rPr>
-                            <m:t>𝑤𝑜𝑟𝑑𝑠</m:t>
-                          </m:r>
-                          <m:r>
-                            <a:rPr lang="en-US" sz="3000" i="1">
-                              <a:solidFill>
-                                <a:schemeClr val="accent6"/>
-                              </a:solidFill>
-                              <a:latin typeface="Cambria Math" panose="02040503050406030204" pitchFamily="18" charset="0"/>
-                              <a:ea typeface="EB Garamond"/>
-                              <a:cs typeface="EB Garamond"/>
-                              <a:sym typeface="EB Garamond"/>
-                            </a:rPr>
-                            <m:t> </m:t>
-                          </m:r>
-                          <m:r>
-                            <a:rPr lang="en-US" sz="3000" i="1">
-                              <a:solidFill>
-                                <a:schemeClr val="accent6"/>
-                              </a:solidFill>
-                              <a:latin typeface="Cambria Math" panose="02040503050406030204" pitchFamily="18" charset="0"/>
-                              <a:ea typeface="EB Garamond"/>
-                              <a:cs typeface="EB Garamond"/>
-                              <a:sym typeface="EB Garamond"/>
-                            </a:rPr>
-                            <m:t>𝑡h𝑎𝑡</m:t>
-                          </m:r>
-                          <m:r>
-                            <a:rPr lang="en-US" sz="3000" i="1">
-                              <a:solidFill>
-                                <a:schemeClr val="accent6"/>
-                              </a:solidFill>
-                              <a:latin typeface="Cambria Math" panose="02040503050406030204" pitchFamily="18" charset="0"/>
-                              <a:ea typeface="EB Garamond"/>
-                              <a:cs typeface="EB Garamond"/>
-                              <a:sym typeface="EB Garamond"/>
-                            </a:rPr>
-                            <m:t> </m:t>
-                          </m:r>
-                          <m:r>
-                            <a:rPr lang="en-US" sz="3000" i="1">
-                              <a:solidFill>
-                                <a:schemeClr val="accent6"/>
-                              </a:solidFill>
-                              <a:latin typeface="Cambria Math" panose="02040503050406030204" pitchFamily="18" charset="0"/>
-                              <a:ea typeface="EB Garamond"/>
-                              <a:cs typeface="EB Garamond"/>
-                              <a:sym typeface="EB Garamond"/>
-                            </a:rPr>
-                            <m:t>𝑜𝑛𝑙𝑦</m:t>
-                          </m:r>
-                          <m:r>
-                            <a:rPr lang="en-US" sz="3000" i="1">
-                              <a:solidFill>
-                                <a:schemeClr val="accent6"/>
-                              </a:solidFill>
-                              <a:latin typeface="Cambria Math" panose="02040503050406030204" pitchFamily="18" charset="0"/>
-                              <a:ea typeface="EB Garamond"/>
-                              <a:cs typeface="EB Garamond"/>
-                              <a:sym typeface="EB Garamond"/>
-                            </a:rPr>
-                            <m:t> </m:t>
-                          </m:r>
-                          <m:r>
-                            <a:rPr lang="en-US" sz="3000" i="1">
-                              <a:solidFill>
-                                <a:schemeClr val="accent6"/>
-                              </a:solidFill>
-                              <a:latin typeface="Cambria Math" panose="02040503050406030204" pitchFamily="18" charset="0"/>
-                              <a:ea typeface="EB Garamond"/>
-                              <a:cs typeface="EB Garamond"/>
-                              <a:sym typeface="EB Garamond"/>
-                            </a:rPr>
-                            <m:t>𝑜𝑐𝑐𝑢𝑟</m:t>
-                          </m:r>
-                          <m:r>
-                            <a:rPr lang="en-US" sz="3000" b="0" i="1" smtClean="0">
-                              <a:solidFill>
-                                <a:schemeClr val="accent6"/>
-                              </a:solidFill>
-                              <a:latin typeface="Cambria Math" panose="02040503050406030204" pitchFamily="18" charset="0"/>
-                              <a:ea typeface="EB Garamond"/>
-                              <a:cs typeface="EB Garamond"/>
-                              <a:sym typeface="EB Garamond"/>
-                            </a:rPr>
-                            <m:t> </m:t>
-                          </m:r>
-                          <m:r>
-                            <a:rPr lang="en-US" sz="3000" b="0" i="1" smtClean="0">
-                              <a:solidFill>
-                                <a:schemeClr val="accent6"/>
-                              </a:solidFill>
-                              <a:latin typeface="Cambria Math" panose="02040503050406030204" pitchFamily="18" charset="0"/>
-                              <a:ea typeface="EB Garamond"/>
-                              <a:cs typeface="EB Garamond"/>
-                              <a:sym typeface="EB Garamond"/>
-                            </a:rPr>
-                            <m:t>𝑜𝑛𝑐𝑒</m:t>
-                          </m:r>
-                        </m:num>
-                        <m:den>
-                          <m:r>
-                            <a:rPr lang="en-US" sz="3000" b="0" i="1" smtClean="0">
-                              <a:solidFill>
-                                <a:schemeClr val="accent6"/>
-                              </a:solidFill>
-                              <a:latin typeface="Cambria Math" panose="02040503050406030204" pitchFamily="18" charset="0"/>
-                              <a:ea typeface="EB Garamond"/>
-                              <a:cs typeface="EB Garamond"/>
-                              <a:sym typeface="EB Garamond"/>
-                            </a:rPr>
-                            <m:t>𝑛𝑢𝑚𝑏𝑒𝑟</m:t>
-                          </m:r>
-                          <m:r>
-                            <a:rPr lang="en-US" sz="3000" b="0" i="1" smtClean="0">
-                              <a:solidFill>
-                                <a:schemeClr val="accent6"/>
-                              </a:solidFill>
-                              <a:latin typeface="Cambria Math" panose="02040503050406030204" pitchFamily="18" charset="0"/>
-                              <a:ea typeface="EB Garamond"/>
-                              <a:cs typeface="EB Garamond"/>
-                              <a:sym typeface="EB Garamond"/>
-                            </a:rPr>
-                            <m:t> </m:t>
-                          </m:r>
-                          <m:r>
-                            <a:rPr lang="en-US" sz="3000" b="0" i="1" smtClean="0">
-                              <a:solidFill>
-                                <a:schemeClr val="accent6"/>
-                              </a:solidFill>
-                              <a:latin typeface="Cambria Math" panose="02040503050406030204" pitchFamily="18" charset="0"/>
-                              <a:ea typeface="EB Garamond"/>
-                              <a:cs typeface="EB Garamond"/>
-                              <a:sym typeface="EB Garamond"/>
-                            </a:rPr>
-                            <m:t>𝑜𝑓</m:t>
-                          </m:r>
-                          <m:r>
-                            <a:rPr lang="en-US" sz="3000" b="0" i="1" smtClean="0">
-                              <a:solidFill>
-                                <a:schemeClr val="accent6"/>
-                              </a:solidFill>
-                              <a:latin typeface="Cambria Math" panose="02040503050406030204" pitchFamily="18" charset="0"/>
-                              <a:ea typeface="EB Garamond"/>
-                              <a:cs typeface="EB Garamond"/>
-                              <a:sym typeface="EB Garamond"/>
-                            </a:rPr>
-                            <m:t> </m:t>
-                          </m:r>
-                          <m:r>
-                            <a:rPr lang="en-US" sz="3000" b="0" i="1" smtClean="0">
-                              <a:solidFill>
-                                <a:schemeClr val="accent6"/>
-                              </a:solidFill>
-                              <a:latin typeface="Cambria Math" panose="02040503050406030204" pitchFamily="18" charset="0"/>
-                              <a:ea typeface="EB Garamond"/>
-                              <a:cs typeface="EB Garamond"/>
-                              <a:sym typeface="EB Garamond"/>
-                            </a:rPr>
-                            <m:t>𝑡𝑜𝑡𝑎𝑙</m:t>
-                          </m:r>
-                          <m:r>
-                            <a:rPr lang="en-US" sz="3000" b="0" i="1" smtClean="0">
-                              <a:solidFill>
-                                <a:schemeClr val="accent6"/>
-                              </a:solidFill>
-                              <a:latin typeface="Cambria Math" panose="02040503050406030204" pitchFamily="18" charset="0"/>
-                              <a:ea typeface="EB Garamond"/>
-                              <a:cs typeface="EB Garamond"/>
-                              <a:sym typeface="EB Garamond"/>
-                            </a:rPr>
-                            <m:t> </m:t>
-                          </m:r>
-                          <m:r>
-                            <a:rPr lang="en-US" sz="3000" b="0" i="1" smtClean="0">
-                              <a:solidFill>
-                                <a:schemeClr val="accent6"/>
-                              </a:solidFill>
-                              <a:latin typeface="Cambria Math" panose="02040503050406030204" pitchFamily="18" charset="0"/>
-                              <a:ea typeface="EB Garamond"/>
-                              <a:cs typeface="EB Garamond"/>
-                              <a:sym typeface="EB Garamond"/>
-                            </a:rPr>
-                            <m:t>𝑤𝑜𝑟𝑑𝑠</m:t>
-                          </m:r>
-                        </m:den>
-                      </m:f>
-                    </m:oMath>
-                  </m:oMathPara>
-                </a14:m>
-                <a:endParaRPr lang="en-US" sz="3000" b="0" dirty="0">
-                  <a:solidFill>
-                    <a:schemeClr val="accent6"/>
-                  </a:solidFill>
-                  <a:latin typeface="EB Garamond"/>
-                  <a:ea typeface="EB Garamond"/>
-                  <a:cs typeface="EB Garamond"/>
-                  <a:sym typeface="EB Garamond"/>
-                </a:endParaRPr>
-              </a:p>
-              <a:p>
-                <a:pPr lvl="0" algn="just"/>
-                <a:endParaRPr lang="en-US" sz="3000" dirty="0">
-                  <a:solidFill>
-                    <a:schemeClr val="accent6"/>
-                  </a:solidFill>
-                  <a:latin typeface="EB Garamond"/>
-                  <a:ea typeface="EB Garamond"/>
-                  <a:cs typeface="EB Garamond"/>
-                  <a:sym typeface="EB Garamond"/>
-                </a:endParaRPr>
-              </a:p>
-              <a:p>
-                <a:pPr lvl="0" algn="just"/>
-                <a:endParaRPr lang="en-US" sz="3000" b="1" dirty="0">
-                  <a:solidFill>
-                    <a:schemeClr val="accent6"/>
-                  </a:solidFill>
-                  <a:latin typeface="EB Garamond"/>
-                  <a:ea typeface="EB Garamond"/>
-                  <a:cs typeface="EB Garamond"/>
-                  <a:sym typeface="EB Garamond"/>
-                </a:endParaRPr>
-              </a:p>
-            </p:txBody>
-          </p:sp>
-        </mc:Choice>
-        <mc:Fallback xmlns="">
-          <p:sp>
-            <p:nvSpPr>
-              <p:cNvPr id="110" name="Google Shape;110;p1"/>
-              <p:cNvSpPr>
-                <a:spLocks noRot="1" noChangeAspect="1" noMove="1" noResize="1" noEditPoints="1" noAdjustHandles="1" noChangeArrowheads="1" noChangeShapeType="1" noTextEdit="1"/>
-              </p:cNvSpPr>
-              <p:nvPr/>
-            </p:nvSpPr>
-            <p:spPr>
-              <a:xfrm>
-                <a:off x="32796053" y="8848013"/>
-                <a:ext cx="9502898" cy="5770963"/>
-              </a:xfrm>
-              <a:prstGeom prst="rect">
-                <a:avLst/>
-              </a:prstGeom>
-              <a:blipFill>
-                <a:blip r:embed="rId5"/>
-                <a:stretch>
-                  <a:fillRect l="-1539" t="-1267"/>
-                </a:stretch>
-              </a:blipFill>
-              <a:ln>
-                <a:noFill/>
-              </a:ln>
-            </p:spPr>
-            <p:txBody>
-              <a:bodyPr/>
-              <a:lstStyle/>
-              <a:p>
-                <a:r>
-                  <a:rPr lang="en-US">
-                    <a:noFill/>
-                  </a:rPr>
-                  <a:t> </a:t>
-                </a:r>
-              </a:p>
-            </p:txBody>
-          </p:sp>
-        </mc:Fallback>
-      </mc:AlternateContent>
       <p:sp>
         <p:nvSpPr>
-          <p:cNvPr id="111" name="Google Shape;111;p1"/>
+          <p:cNvPr id="110" name="Google Shape;110;p1"/>
           <p:cNvSpPr/>
           <p:nvPr/>
         </p:nvSpPr>
         <p:spPr>
           <a:xfrm>
-            <a:off x="32796052" y="27343869"/>
-            <a:ext cx="9583737" cy="4893607"/>
+            <a:off x="32796053" y="8848013"/>
+            <a:ext cx="9502898" cy="553957"/>
           </a:xfrm>
           <a:prstGeom prst="rect">
             <a:avLst/>
@@ -13871,7 +12532,7 @@
           </a:bodyPr>
           <a:lstStyle/>
           <a:p>
-            <a:pPr marL="914400" marR="0" lvl="0" indent="-914400" rtl="0">
+            <a:pPr marL="0" marR="0" lvl="0" indent="0" algn="just" rtl="0">
               <a:spcBef>
                 <a:spcPts val="0"/>
               </a:spcBef>
@@ -13881,7 +12542,7 @@
               <a:buNone/>
             </a:pPr>
             <a:r>
-              <a:rPr lang="en-US" sz="2400" dirty="0">
+              <a:rPr lang="en-US" sz="3000" b="1" dirty="0">
                 <a:solidFill>
                   <a:schemeClr val="accent6"/>
                 </a:solidFill>
@@ -13890,129 +12551,225 @@
                 <a:cs typeface="EB Garamond"/>
                 <a:sym typeface="EB Garamond"/>
               </a:rPr>
-              <a:t>[1] </a:t>
+              <a:t>Start</a:t>
             </a:r>
-            <a:r>
-              <a:rPr lang="en-US" sz="2400" dirty="0" err="1">
-                <a:solidFill>
-                  <a:schemeClr val="accent6"/>
-                </a:solidFill>
-                <a:latin typeface="EB Garamond"/>
-                <a:ea typeface="EB Garamond"/>
-                <a:cs typeface="EB Garamond"/>
-                <a:sym typeface="EB Garamond"/>
-              </a:rPr>
-              <a:t>Yaden</a:t>
-            </a:r>
+          </a:p>
+        </p:txBody>
+      </p:sp>
+      <p:sp>
+        <p:nvSpPr>
+          <p:cNvPr id="111" name="Google Shape;111;p1"/>
+          <p:cNvSpPr/>
+          <p:nvPr/>
+        </p:nvSpPr>
+        <p:spPr>
+          <a:xfrm>
+            <a:off x="32796052" y="26897304"/>
+            <a:ext cx="9909931" cy="5632271"/>
+          </a:xfrm>
+          <a:prstGeom prst="rect">
+            <a:avLst/>
+          </a:prstGeom>
+          <a:noFill/>
+          <a:ln>
+            <a:noFill/>
+          </a:ln>
+        </p:spPr>
+        <p:txBody>
+          <a:bodyPr spcFirstLastPara="1" wrap="square" lIns="91425" tIns="45700" rIns="91425" bIns="45700" anchor="t" anchorCtr="0">
+            <a:spAutoFit/>
+          </a:bodyPr>
+          <a:lstStyle/>
+          <a:p>
+            <a:pPr marL="914400" lvl="0" indent="-914400"/>
             <a:r>
               <a:rPr lang="en-US" sz="2400" dirty="0">
                 <a:solidFill>
                   <a:schemeClr val="accent6"/>
                 </a:solidFill>
-                <a:latin typeface="EB Garamond"/>
-                <a:ea typeface="EB Garamond"/>
+                <a:latin typeface="EB Garamond" pitchFamily="2" charset="0"/>
+                <a:ea typeface="EB Garamond" pitchFamily="2" charset="0"/>
                 <a:cs typeface="EB Garamond"/>
                 <a:sym typeface="EB Garamond"/>
               </a:rPr>
-              <a:t>, D. B., Giorgi, S., Jordan, M., </a:t>
+              <a:t>[1] </a:t>
             </a:r>
             <a:r>
-              <a:rPr lang="en-US" sz="2400" dirty="0" err="1">
-                <a:solidFill>
-                  <a:schemeClr val="accent6"/>
-                </a:solidFill>
-                <a:latin typeface="EB Garamond"/>
-                <a:ea typeface="EB Garamond"/>
-                <a:cs typeface="EB Garamond"/>
-                <a:sym typeface="EB Garamond"/>
+              <a:rPr lang="en-US" sz="2400" dirty="0">
+                <a:latin typeface="EB Garamond" pitchFamily="2" charset="0"/>
+                <a:ea typeface="EB Garamond" pitchFamily="2" charset="0"/>
               </a:rPr>
-              <a:t>Buffone</a:t>
+              <a:t>Balboni, C., Burgess, R., &amp; Olken, B. A. (2025). The origins and control of forest fires in the tropics. </a:t>
             </a:r>
+            <a:r>
+              <a:rPr lang="en-US" sz="2400" i="1" dirty="0">
+                <a:latin typeface="EB Garamond" pitchFamily="2" charset="0"/>
+                <a:ea typeface="EB Garamond" pitchFamily="2" charset="0"/>
+              </a:rPr>
+              <a:t>Review of Economic Studies</a:t>
+            </a:r>
+            <a:r>
+              <a:rPr lang="en-US" sz="2400" dirty="0">
+                <a:latin typeface="EB Garamond" pitchFamily="2" charset="0"/>
+                <a:ea typeface="EB Garamond" pitchFamily="2" charset="0"/>
+              </a:rPr>
+              <a:t>.</a:t>
+            </a:r>
+          </a:p>
+          <a:p>
+            <a:pPr marL="914400" lvl="0" indent="-914400"/>
             <a:r>
               <a:rPr lang="en-US" sz="2400" dirty="0">
                 <a:solidFill>
                   <a:schemeClr val="accent6"/>
                 </a:solidFill>
-                <a:latin typeface="EB Garamond"/>
-                <a:ea typeface="EB Garamond"/>
+                <a:latin typeface="EB Garamond" pitchFamily="2" charset="0"/>
+                <a:ea typeface="EB Garamond" pitchFamily="2" charset="0"/>
                 <a:cs typeface="EB Garamond"/>
                 <a:sym typeface="EB Garamond"/>
               </a:rPr>
-              <a:t>, A., Eichstaedt, J. C., Schwartz, H. A., Ungar, L., &amp; Bloom, P. (2024). Characterizing empathy and compassion using computational linguistic analysis. Emotion, 24(1), 106–115. https://doi-org.libdata.lib.ua.edu/10.1037/emo0001205.supp (Supplemental)</a:t>
+              <a:t>[2] </a:t>
             </a:r>
-            <a:endParaRPr lang="en-US" dirty="0"/>
+            <a:r>
+              <a:rPr lang="en-US" sz="2400" dirty="0">
+                <a:latin typeface="EB Garamond" pitchFamily="2" charset="0"/>
+                <a:ea typeface="EB Garamond" pitchFamily="2" charset="0"/>
+              </a:rPr>
+              <a:t>Burgess, R., Hansen, M., Olken, B. A., Potapov, P., &amp; Sieber, S. (2012). The political economy of deforestation in the tropics. </a:t>
+            </a:r>
+            <a:r>
+              <a:rPr lang="en-US" sz="2400" i="1" dirty="0">
+                <a:latin typeface="EB Garamond" pitchFamily="2" charset="0"/>
+                <a:ea typeface="EB Garamond" pitchFamily="2" charset="0"/>
+              </a:rPr>
+              <a:t>The Quarterly Journal of Economics, 127</a:t>
+            </a:r>
+            <a:r>
+              <a:rPr lang="en-US" sz="2400" dirty="0">
+                <a:latin typeface="EB Garamond" pitchFamily="2" charset="0"/>
+                <a:ea typeface="EB Garamond" pitchFamily="2" charset="0"/>
+              </a:rPr>
+              <a:t>(4), 1707-1754.</a:t>
+            </a:r>
           </a:p>
           <a:p>
-            <a:pPr marL="914400" marR="0" lvl="0" indent="-914400" rtl="0">
-              <a:spcBef>
-                <a:spcPts val="0"/>
-              </a:spcBef>
-              <a:spcAft>
-                <a:spcPts val="0"/>
-              </a:spcAft>
-              <a:buNone/>
-            </a:pPr>
+            <a:pPr marL="914400" lvl="0" indent="-914400"/>
             <a:r>
               <a:rPr lang="en-US" sz="2400" dirty="0">
                 <a:solidFill>
                   <a:schemeClr val="accent6"/>
                 </a:solidFill>
-                <a:latin typeface="EB Garamond"/>
-                <a:ea typeface="EB Garamond"/>
+                <a:latin typeface="EB Garamond" pitchFamily="2" charset="0"/>
+                <a:ea typeface="EB Garamond" pitchFamily="2" charset="0"/>
                 <a:cs typeface="EB Garamond"/>
                 <a:sym typeface="EB Garamond"/>
               </a:rPr>
-              <a:t>[2] Baek, Y. M., </a:t>
+              <a:t>[3] </a:t>
+            </a:r>
+            <a:r>
+              <a:rPr lang="en-US" sz="2400" dirty="0">
+                <a:latin typeface="EB Garamond" pitchFamily="2" charset="0"/>
+                <a:ea typeface="EB Garamond" pitchFamily="2" charset="0"/>
+              </a:rPr>
+              <a:t>Homer-Dixon, T. F. (1994). Environmental scarcities and violent conflict: evidence from cases. </a:t>
+            </a:r>
+            <a:r>
+              <a:rPr lang="en-US" sz="2400" i="1" dirty="0">
+                <a:latin typeface="EB Garamond" pitchFamily="2" charset="0"/>
+                <a:ea typeface="EB Garamond" pitchFamily="2" charset="0"/>
+              </a:rPr>
+              <a:t>International Security, 19</a:t>
+            </a:r>
+            <a:r>
+              <a:rPr lang="en-US" sz="2400" dirty="0">
+                <a:latin typeface="EB Garamond" pitchFamily="2" charset="0"/>
+                <a:ea typeface="EB Garamond" pitchFamily="2" charset="0"/>
+              </a:rPr>
+              <a:t>(1), 5-40.</a:t>
+            </a:r>
+          </a:p>
+          <a:p>
+            <a:r>
+              <a:rPr lang="en-US" sz="2400" dirty="0">
+                <a:latin typeface="EB Garamond" pitchFamily="2" charset="0"/>
+                <a:ea typeface="EB Garamond" pitchFamily="2" charset="0"/>
+              </a:rPr>
+              <a:t>[4] Burke, M. B., Miguel, E., </a:t>
             </a:r>
             <a:r>
               <a:rPr lang="en-US" sz="2400" dirty="0" err="1">
-                <a:solidFill>
-                  <a:schemeClr val="accent6"/>
-                </a:solidFill>
-                <a:latin typeface="EB Garamond"/>
-                <a:ea typeface="EB Garamond"/>
-                <a:cs typeface="EB Garamond"/>
-                <a:sym typeface="EB Garamond"/>
+                <a:latin typeface="EB Garamond" pitchFamily="2" charset="0"/>
+                <a:ea typeface="EB Garamond" pitchFamily="2" charset="0"/>
               </a:rPr>
-              <a:t>Ihm</a:t>
+              <a:t>Satyanath</a:t>
             </a:r>
             <a:r>
               <a:rPr lang="en-US" sz="2400" dirty="0">
-                <a:solidFill>
-                  <a:schemeClr val="accent6"/>
-                </a:solidFill>
-                <a:latin typeface="EB Garamond"/>
-                <a:ea typeface="EB Garamond"/>
-                <a:cs typeface="EB Garamond"/>
-                <a:sym typeface="EB Garamond"/>
+                <a:latin typeface="EB Garamond" pitchFamily="2" charset="0"/>
+                <a:ea typeface="EB Garamond" pitchFamily="2" charset="0"/>
               </a:rPr>
-              <a:t>, J., &amp; Kang, C. H. (2023). Does mission concreteness make a difference in nonprofit performance? Automated text analysis approach to the importance of concrete mission statements. Nonprofit Management &amp; Leadership, 34(2), 409–431. https://doi-org.libdata.lib.ua.edu/10.1002/nml.21570</a:t>
+              <a:t>, S., Dykema, J. A., &amp; Lobell, D. B. (2009). 	Warming increases the risk of civil war in Africa. </a:t>
             </a:r>
-            <a:endParaRPr lang="en-US" dirty="0"/>
+            <a:r>
+              <a:rPr lang="en-US" sz="2400" i="1" dirty="0">
+                <a:latin typeface="EB Garamond" pitchFamily="2" charset="0"/>
+                <a:ea typeface="EB Garamond" pitchFamily="2" charset="0"/>
+              </a:rPr>
+              <a:t>Proceedings of the National 	Academy of Sciences, 106</a:t>
+            </a:r>
+            <a:r>
+              <a:rPr lang="en-US" sz="2400" dirty="0">
+                <a:latin typeface="EB Garamond" pitchFamily="2" charset="0"/>
+                <a:ea typeface="EB Garamond" pitchFamily="2" charset="0"/>
+              </a:rPr>
+              <a:t>(49), 20670-20674.</a:t>
+            </a:r>
           </a:p>
           <a:p>
-            <a:pPr marL="914400" marR="0" lvl="0" indent="-914400" rtl="0">
-              <a:spcBef>
-                <a:spcPts val="0"/>
-              </a:spcBef>
-              <a:spcAft>
-                <a:spcPts val="0"/>
-              </a:spcAft>
-              <a:buNone/>
-            </a:pPr>
             <a:r>
               <a:rPr lang="en-US" sz="2400" dirty="0">
-                <a:solidFill>
-                  <a:schemeClr val="accent6"/>
-                </a:solidFill>
-                <a:latin typeface="EB Garamond"/>
-                <a:ea typeface="EB Garamond"/>
-                <a:cs typeface="EB Garamond"/>
-                <a:sym typeface="EB Garamond"/>
+                <a:latin typeface="EB Garamond" pitchFamily="2" charset="0"/>
+                <a:ea typeface="EB Garamond" pitchFamily="2" charset="0"/>
               </a:rPr>
-              <a:t>[3] Ward, B. (2023). Relationship Between Mission Statement Components and ROA: A Study of Small-Cap Financial Firms. IUP Journal of Business Strategy, 20(4), 5–19.</a:t>
+              <a:t>[5] Hsiang, S. M., Burke, M., &amp; Miguel, E. (2013). Quantifying the influence of 	climate on human conflict. </a:t>
             </a:r>
-            <a:endParaRPr dirty="0"/>
+            <a:r>
+              <a:rPr lang="en-US" sz="2400" i="1" dirty="0">
+                <a:latin typeface="EB Garamond" pitchFamily="2" charset="0"/>
+                <a:ea typeface="EB Garamond" pitchFamily="2" charset="0"/>
+              </a:rPr>
+              <a:t>Science, 341</a:t>
+            </a:r>
+            <a:r>
+              <a:rPr lang="en-US" sz="2400" dirty="0">
+                <a:latin typeface="EB Garamond" pitchFamily="2" charset="0"/>
+                <a:ea typeface="EB Garamond" pitchFamily="2" charset="0"/>
+              </a:rPr>
+              <a:t>(6151), 1235367.</a:t>
+            </a:r>
+          </a:p>
+          <a:p>
+            <a:r>
+              <a:rPr lang="en-US" sz="2400" dirty="0">
+                <a:latin typeface="EB Garamond" pitchFamily="2" charset="0"/>
+                <a:ea typeface="EB Garamond" pitchFamily="2" charset="0"/>
+              </a:rPr>
+              <a:t>[6] Dell, M., Jones, B. F., &amp; Olken, B. A. (2012). Temperature shocks and economic 	growth: Evidence from the last half century. </a:t>
+            </a:r>
+            <a:r>
+              <a:rPr lang="en-US" sz="2400" i="1" dirty="0">
+                <a:latin typeface="EB Garamond" pitchFamily="2" charset="0"/>
+                <a:ea typeface="EB Garamond" pitchFamily="2" charset="0"/>
+              </a:rPr>
+              <a:t>American Economic Journal: 	Macroeconomics, 4</a:t>
+            </a:r>
+            <a:r>
+              <a:rPr lang="en-US" sz="2400" dirty="0">
+                <a:latin typeface="EB Garamond" pitchFamily="2" charset="0"/>
+                <a:ea typeface="EB Garamond" pitchFamily="2" charset="0"/>
+              </a:rPr>
+              <a:t>(3), 66-95.</a:t>
+            </a:r>
           </a:p>
         </p:txBody>
       </p:sp>
@@ -15841,7 +14598,7 @@
         </p:nvSpPr>
         <p:spPr>
           <a:xfrm>
-            <a:off x="867624" y="24964350"/>
+            <a:off x="867624" y="19052651"/>
             <a:ext cx="10241280" cy="914400"/>
           </a:xfrm>
           <a:prstGeom prst="rect">
@@ -15896,7 +14653,7 @@
         </p:nvSpPr>
         <p:spPr>
           <a:xfrm>
-            <a:off x="1550567" y="25023087"/>
+            <a:off x="1550567" y="19111388"/>
             <a:ext cx="9083675" cy="769938"/>
           </a:xfrm>
           <a:prstGeom prst="rect">
@@ -15930,7 +14687,7 @@
               <a:buNone/>
             </a:pPr>
             <a:r>
-              <a:rPr lang="en-US" sz="4400">
+              <a:rPr lang="en-US" sz="4400" dirty="0">
                 <a:solidFill>
                   <a:schemeClr val="lt1"/>
                 </a:solidFill>
@@ -15939,9 +14696,9 @@
                 <a:cs typeface="Verdana"/>
                 <a:sym typeface="Verdana"/>
               </a:rPr>
-              <a:t>MOTIVATION</a:t>
+              <a:t>LITERATURE AND CONTEXT</a:t>
             </a:r>
-            <a:endParaRPr/>
+            <a:endParaRPr dirty="0"/>
           </a:p>
         </p:txBody>
       </p:sp>
@@ -16051,7 +14808,7 @@
                 <a:cs typeface="Verdana"/>
                 <a:sym typeface="Verdana"/>
               </a:rPr>
-              <a:t>PRELIMINARY RESULTS</a:t>
+              <a:t>FINDINGS</a:t>
             </a:r>
             <a:endParaRPr dirty="0"/>
           </a:p>
@@ -16059,14 +14816,14 @@
       </p:sp>
       <p:sp>
         <p:nvSpPr>
-          <p:cNvPr id="167" name="Google Shape;167;p1"/>
+          <p:cNvPr id="168" name="Google Shape;168;p1"/>
           <p:cNvSpPr/>
           <p:nvPr/>
         </p:nvSpPr>
         <p:spPr>
           <a:xfrm>
-            <a:off x="14489015" y="32084775"/>
-            <a:ext cx="14618652" cy="646290"/>
+            <a:off x="1080319" y="20117106"/>
+            <a:ext cx="9989816" cy="12095579"/>
           </a:xfrm>
           <a:prstGeom prst="rect">
             <a:avLst/>
@@ -16082,331 +14839,124 @@
           </a:bodyPr>
           <a:lstStyle/>
           <a:p>
-            <a:pPr marL="0" marR="0" lvl="0" indent="0" algn="ctr" rtl="0">
-              <a:spcBef>
-                <a:spcPts val="0"/>
-              </a:spcBef>
-              <a:spcAft>
-                <a:spcPts val="0"/>
-              </a:spcAft>
-              <a:buNone/>
-            </a:pPr>
             <a:r>
-              <a:rPr lang="en-US" sz="3600" dirty="0">
-                <a:solidFill>
-                  <a:schemeClr val="accent6"/>
-                </a:solidFill>
-                <a:latin typeface="EB Garamond"/>
-                <a:ea typeface="EB Garamond"/>
-                <a:cs typeface="EB Garamond"/>
-                <a:sym typeface="EB Garamond"/>
+              <a:rPr lang="en-US" sz="3000" b="1" dirty="0">
+                <a:latin typeface="EB Garamond" pitchFamily="2" charset="0"/>
+                <a:ea typeface="EB Garamond" pitchFamily="2" charset="0"/>
               </a:rPr>
-              <a:t>Table 1: Preprocessed Missions and Revenues of Tax-Exempt Organizations</a:t>
+              <a:t>Climate Shocks and Conflict</a:t>
             </a:r>
-            <a:endParaRPr dirty="0"/>
-          </a:p>
-        </p:txBody>
-      </p:sp>
-      <p:sp>
-        <p:nvSpPr>
-          <p:cNvPr id="168" name="Google Shape;168;p1"/>
-          <p:cNvSpPr/>
-          <p:nvPr/>
-        </p:nvSpPr>
-        <p:spPr>
-          <a:xfrm>
-            <a:off x="1080319" y="26028805"/>
-            <a:ext cx="9809347" cy="6093936"/>
-          </a:xfrm>
-          <a:prstGeom prst="rect">
-            <a:avLst/>
-          </a:prstGeom>
-          <a:noFill/>
-          <a:ln>
-            <a:noFill/>
-          </a:ln>
-        </p:spPr>
-        <p:txBody>
-          <a:bodyPr spcFirstLastPara="1" wrap="square" lIns="91425" tIns="45700" rIns="91425" bIns="45700" anchor="t" anchorCtr="0">
-            <a:spAutoFit/>
-          </a:bodyPr>
-          <a:lstStyle/>
-          <a:p>
-            <a:pPr marL="0" marR="0" lvl="0" indent="0" algn="just" rtl="0">
-              <a:spcBef>
-                <a:spcPts val="0"/>
-              </a:spcBef>
-              <a:spcAft>
-                <a:spcPts val="0"/>
-              </a:spcAft>
-              <a:buNone/>
-            </a:pPr>
+            <a:br>
+              <a:rPr lang="en-US" sz="3000" dirty="0">
+                <a:latin typeface="EB Garamond" pitchFamily="2" charset="0"/>
+                <a:ea typeface="EB Garamond" pitchFamily="2" charset="0"/>
+              </a:rPr>
+            </a:br>
             <a:r>
               <a:rPr lang="en-US" sz="3000" dirty="0">
-                <a:solidFill>
-                  <a:schemeClr val="accent6"/>
-                </a:solidFill>
-                <a:latin typeface="EB Garamond"/>
-                <a:ea typeface="EB Garamond"/>
-                <a:cs typeface="EB Garamond"/>
-                <a:sym typeface="EB Garamond"/>
+                <a:latin typeface="EB Garamond" pitchFamily="2" charset="0"/>
+                <a:ea typeface="EB Garamond" pitchFamily="2" charset="0"/>
               </a:rPr>
-              <a:t>The nonprofit sector largely consists of small, community-based organizations working with meager resources. For this reason, nonprofits rely on resources and research to operate more effectively. Prior researchers have begun to understand the impact of different linguistic structures and patterns on economic and organizational performance. This project furthers these efforts by addressing a research gap surrounding empathy and compassion in mission statements. We evaluate the impact of “Self VS Other" linguistic structures on revenues of tax-exempt organizations. This research will provide a better understanding of the impact of linguistic features and can be applied to increase charitable donations and elevate the impact of a wide array of nonprofits, thereby touching the lives of countless individuals.</a:t>
+              <a:t>Burke et al. (2009), Dell et al. (2012), and Hsiang et al. (2013) collectively establish that climatic shocks — including temperature increases and extreme weather events — significantly raise civil conflict incidence, reduce economic output, and destabilize political institutions across diverse global contexts.</a:t>
             </a:r>
           </a:p>
-        </p:txBody>
-      </p:sp>
-      <p:sp>
-        <p:nvSpPr>
-          <p:cNvPr id="169" name="Google Shape;169;p1"/>
-          <p:cNvSpPr/>
-          <p:nvPr/>
-        </p:nvSpPr>
-        <p:spPr>
-          <a:xfrm>
-            <a:off x="32607945" y="14329746"/>
-            <a:ext cx="10241280" cy="914400"/>
-          </a:xfrm>
-          <a:prstGeom prst="rect">
-            <a:avLst/>
-          </a:prstGeom>
-          <a:solidFill>
-            <a:srgbClr val="9C2334"/>
-          </a:solidFill>
-          <a:ln>
-            <a:noFill/>
-          </a:ln>
-          <a:effectLst>
-            <a:outerShdw blurRad="50800" dist="38100" dir="5400000" algn="t" rotWithShape="0">
-              <a:srgbClr val="000000">
-                <a:alpha val="40000"/>
-              </a:srgbClr>
-            </a:outerShdw>
-          </a:effectLst>
-        </p:spPr>
-        <p:txBody>
-          <a:bodyPr spcFirstLastPara="1" wrap="square" lIns="91425" tIns="45700" rIns="91425" bIns="45700" anchor="ctr" anchorCtr="0">
-            <a:noAutofit/>
-          </a:bodyPr>
-          <a:lstStyle/>
           <a:p>
-            <a:pPr marL="0" marR="0" lvl="0" indent="0" algn="ctr" rtl="0">
-              <a:spcBef>
-                <a:spcPts val="0"/>
-              </a:spcBef>
-              <a:spcAft>
-                <a:spcPts val="0"/>
-              </a:spcAft>
-              <a:buNone/>
-            </a:pPr>
-            <a:endParaRPr sz="8600">
-              <a:solidFill>
-                <a:schemeClr val="lt1"/>
-              </a:solidFill>
-              <a:latin typeface="Corbel"/>
-              <a:ea typeface="Corbel"/>
-              <a:cs typeface="Corbel"/>
-              <a:sym typeface="Corbel"/>
+            <a:endParaRPr lang="en-US" sz="3000" b="1" dirty="0">
+              <a:latin typeface="EB Garamond" pitchFamily="2" charset="0"/>
+              <a:ea typeface="EB Garamond" pitchFamily="2" charset="0"/>
             </a:endParaRPr>
           </a:p>
-        </p:txBody>
-      </p:sp>
-      <p:sp>
-        <p:nvSpPr>
-          <p:cNvPr id="170" name="Google Shape;170;p1"/>
-          <p:cNvSpPr txBox="1"/>
-          <p:nvPr/>
-        </p:nvSpPr>
-        <p:spPr>
-          <a:xfrm>
-            <a:off x="33290888" y="14388483"/>
-            <a:ext cx="9083675" cy="769938"/>
-          </a:xfrm>
-          <a:prstGeom prst="rect">
-            <a:avLst/>
-          </a:prstGeom>
-          <a:noFill/>
-          <a:ln>
-            <a:noFill/>
-          </a:ln>
-          <a:effectLst>
-            <a:outerShdw blurRad="40000" dist="20000" dir="5400000" rotWithShape="0">
-              <a:srgbClr val="000000">
-                <a:alpha val="37647"/>
-              </a:srgbClr>
-            </a:outerShdw>
-          </a:effectLst>
-        </p:spPr>
-        <p:txBody>
-          <a:bodyPr spcFirstLastPara="1" wrap="square" lIns="91425" tIns="45700" rIns="91425" bIns="45700" anchor="t" anchorCtr="0">
-            <a:spAutoFit/>
-          </a:bodyPr>
-          <a:lstStyle/>
           <a:p>
-            <a:pPr marL="0" marR="0" lvl="0" indent="0" algn="ctr" rtl="0">
-              <a:spcBef>
-                <a:spcPts val="0"/>
-              </a:spcBef>
-              <a:spcAft>
-                <a:spcPts val="0"/>
-              </a:spcAft>
-              <a:buNone/>
-            </a:pPr>
             <a:r>
-              <a:rPr lang="en-US" sz="4400" dirty="0">
-                <a:solidFill>
-                  <a:schemeClr val="lt1"/>
-                </a:solidFill>
-                <a:latin typeface="Verdana"/>
-                <a:ea typeface="Verdana"/>
-                <a:cs typeface="Verdana"/>
-                <a:sym typeface="Verdana"/>
+              <a:rPr lang="en-US" sz="3000" b="1" dirty="0">
+                <a:latin typeface="EB Garamond" pitchFamily="2" charset="0"/>
+                <a:ea typeface="EB Garamond" pitchFamily="2" charset="0"/>
               </a:rPr>
-              <a:t>HYPOTHESES</a:t>
+              <a:t>Resource Scarcity &amp; Violence</a:t>
             </a:r>
-            <a:endParaRPr dirty="0"/>
-          </a:p>
-        </p:txBody>
-      </p:sp>
-      <p:sp>
-        <p:nvSpPr>
-          <p:cNvPr id="171" name="Google Shape;171;p1"/>
-          <p:cNvSpPr/>
-          <p:nvPr/>
-        </p:nvSpPr>
-        <p:spPr>
-          <a:xfrm>
-            <a:off x="32790827" y="15570684"/>
-            <a:ext cx="9502898" cy="5170606"/>
-          </a:xfrm>
-          <a:prstGeom prst="rect">
-            <a:avLst/>
-          </a:prstGeom>
-          <a:noFill/>
-          <a:ln>
-            <a:noFill/>
-          </a:ln>
-        </p:spPr>
-        <p:txBody>
-          <a:bodyPr spcFirstLastPara="1" wrap="square" lIns="91425" tIns="45700" rIns="91425" bIns="45700" anchor="t" anchorCtr="0">
-            <a:spAutoFit/>
-          </a:bodyPr>
-          <a:lstStyle/>
-          <a:p>
-            <a:pPr marL="514350" marR="0" lvl="0" indent="-514350" algn="just" rtl="0">
-              <a:spcBef>
-                <a:spcPts val="0"/>
-              </a:spcBef>
-              <a:spcAft>
-                <a:spcPts val="0"/>
-              </a:spcAft>
-              <a:buClr>
-                <a:schemeClr val="accent6"/>
-              </a:buClr>
-              <a:buSzPts val="3000"/>
-              <a:buFont typeface="Corbel"/>
-              <a:buAutoNum type="arabicPeriod"/>
-            </a:pPr>
+            <a:br>
+              <a:rPr lang="en-US" sz="3000" dirty="0">
+                <a:latin typeface="EB Garamond" pitchFamily="2" charset="0"/>
+                <a:ea typeface="EB Garamond" pitchFamily="2" charset="0"/>
+              </a:rPr>
+            </a:br>
             <a:r>
               <a:rPr lang="en-US" sz="3000" dirty="0">
-                <a:solidFill>
-                  <a:schemeClr val="accent6"/>
-                </a:solidFill>
-                <a:latin typeface="EB Garamond"/>
-                <a:ea typeface="EB Garamond"/>
-                <a:cs typeface="EB Garamond"/>
-                <a:sym typeface="EB Garamond"/>
+                <a:latin typeface="EB Garamond" pitchFamily="2" charset="0"/>
+                <a:ea typeface="EB Garamond" pitchFamily="2" charset="0"/>
               </a:rPr>
-              <a:t>Mission statement language will correlate with revenue of tax-exempt organizations.</a:t>
+              <a:t>Homer-Dixon (1994) argues that environmental scarcity generates conflict through livelihood disruption and group grievance — a framework directly applicable to rural Indonesia, where agricultural dependence is high and customary land rights are frequently contested by corporate concession holders.</a:t>
             </a:r>
-            <a:endParaRPr dirty="0"/>
           </a:p>
           <a:p>
-            <a:pPr marL="514350" marR="0" lvl="0" indent="-514350" algn="just" rtl="0">
-              <a:spcBef>
-                <a:spcPts val="1200"/>
-              </a:spcBef>
-              <a:spcAft>
-                <a:spcPts val="0"/>
-              </a:spcAft>
-              <a:buClr>
-                <a:schemeClr val="accent6"/>
-              </a:buClr>
-              <a:buSzPts val="3000"/>
-              <a:buFont typeface="Corbel"/>
-              <a:buAutoNum type="arabicPeriod"/>
-            </a:pPr>
+            <a:endParaRPr lang="en-US" sz="3000" b="1" dirty="0">
+              <a:latin typeface="EB Garamond" pitchFamily="2" charset="0"/>
+              <a:ea typeface="EB Garamond" pitchFamily="2" charset="0"/>
+            </a:endParaRPr>
+          </a:p>
+          <a:p>
+            <a:r>
+              <a:rPr lang="en-US" sz="3000" b="1" dirty="0">
+                <a:latin typeface="EB Garamond" pitchFamily="2" charset="0"/>
+                <a:ea typeface="EB Garamond" pitchFamily="2" charset="0"/>
+              </a:rPr>
+              <a:t>Indonesia-Specific Context</a:t>
+            </a:r>
+            <a:br>
+              <a:rPr lang="en-US" sz="3000" dirty="0">
+                <a:latin typeface="EB Garamond" pitchFamily="2" charset="0"/>
+                <a:ea typeface="EB Garamond" pitchFamily="2" charset="0"/>
+              </a:rPr>
+            </a:br>
             <a:r>
               <a:rPr lang="en-US" sz="3000" dirty="0">
-                <a:solidFill>
-                  <a:schemeClr val="accent6"/>
-                </a:solidFill>
-                <a:latin typeface="EB Garamond"/>
-                <a:ea typeface="EB Garamond"/>
-                <a:cs typeface="EB Garamond"/>
-                <a:sym typeface="EB Garamond"/>
+                <a:latin typeface="EB Garamond" pitchFamily="2" charset="0"/>
+                <a:ea typeface="EB Garamond" pitchFamily="2" charset="0"/>
               </a:rPr>
-              <a:t>Mission statements with language identifying as more donor-serving will correlate with higher revenue.</a:t>
+              <a:t>Fires in Indonesia are driven by El Niño-induced drought, illegal land clearing for palm oil, and drainage of carbon-rich peatlands. Burgess et al. (2012) and Balboni et al. (2025) show that political incentives and weak property rights enforcement make fire risk in the region a deeply institutional phenomenon.</a:t>
             </a:r>
-            <a:endParaRPr dirty="0"/>
           </a:p>
           <a:p>
-            <a:pPr marL="514350" marR="0" lvl="0" indent="-514350" algn="just" rtl="0">
-              <a:spcBef>
-                <a:spcPts val="1200"/>
-              </a:spcBef>
-              <a:spcAft>
-                <a:spcPts val="0"/>
-              </a:spcAft>
-              <a:buClr>
-                <a:schemeClr val="accent6"/>
-              </a:buClr>
-              <a:buSzPts val="3000"/>
-              <a:buFont typeface="Corbel"/>
-              <a:buAutoNum type="arabicPeriod"/>
-            </a:pPr>
+            <a:endParaRPr lang="en-US" sz="3000" b="1" dirty="0">
+              <a:latin typeface="EB Garamond" pitchFamily="2" charset="0"/>
+              <a:ea typeface="EB Garamond" pitchFamily="2" charset="0"/>
+            </a:endParaRPr>
+          </a:p>
+          <a:p>
+            <a:r>
+              <a:rPr lang="en-US" sz="3000" b="1" dirty="0">
+                <a:latin typeface="EB Garamond" pitchFamily="2" charset="0"/>
+                <a:ea typeface="EB Garamond" pitchFamily="2" charset="0"/>
+              </a:rPr>
+              <a:t>Research Gap</a:t>
+            </a:r>
+            <a:br>
+              <a:rPr lang="en-US" sz="3000" dirty="0">
+                <a:latin typeface="EB Garamond" pitchFamily="2" charset="0"/>
+                <a:ea typeface="EB Garamond" pitchFamily="2" charset="0"/>
+              </a:rPr>
+            </a:br>
             <a:r>
               <a:rPr lang="en-US" sz="3000" dirty="0">
-                <a:solidFill>
-                  <a:schemeClr val="accent6"/>
-                </a:solidFill>
-                <a:latin typeface="EB Garamond"/>
-                <a:ea typeface="EB Garamond"/>
-                <a:cs typeface="EB Garamond"/>
-                <a:sym typeface="EB Garamond"/>
+                <a:latin typeface="EB Garamond" pitchFamily="2" charset="0"/>
+                <a:ea typeface="EB Garamond" pitchFamily="2" charset="0"/>
               </a:rPr>
-              <a:t>The effects of mission statement language on revenue will be less powerful for tax-exempt organizations with higher asset codes. </a:t>
+              <a:t>While the literature addresses climate-conflict links and Indonesian fire dynamics, no study directly estimates </a:t>
             </a:r>
-            <a:endParaRPr dirty="0"/>
-          </a:p>
-          <a:p>
-            <a:pPr marL="514350" marR="0" lvl="0" indent="-514350" algn="just" rtl="0">
-              <a:spcBef>
-                <a:spcPts val="1200"/>
-              </a:spcBef>
-              <a:spcAft>
-                <a:spcPts val="0"/>
-              </a:spcAft>
-              <a:buClr>
-                <a:schemeClr val="accent6"/>
-              </a:buClr>
-              <a:buSzPts val="3000"/>
-              <a:buFont typeface="Corbel"/>
-              <a:buAutoNum type="arabicPeriod"/>
-            </a:pPr>
+            <a:r>
+              <a:rPr lang="en-US" sz="3000" i="1" dirty="0">
+                <a:latin typeface="EB Garamond" pitchFamily="2" charset="0"/>
+                <a:ea typeface="EB Garamond" pitchFamily="2" charset="0"/>
+              </a:rPr>
+              <a:t>causal</a:t>
+            </a:r>
             <a:r>
               <a:rPr lang="en-US" sz="3000" dirty="0">
-                <a:solidFill>
-                  <a:schemeClr val="accent6"/>
-                </a:solidFill>
-                <a:latin typeface="EB Garamond"/>
-                <a:ea typeface="EB Garamond"/>
-                <a:cs typeface="EB Garamond"/>
-                <a:sym typeface="EB Garamond"/>
+                <a:latin typeface="EB Garamond" pitchFamily="2" charset="0"/>
+                <a:ea typeface="EB Garamond" pitchFamily="2" charset="0"/>
               </a:rPr>
-              <a:t>The effects of mission statement language on revenue will differ slightly among categories of tax-exempt organizations, such as education versus health nonprofits.</a:t>
+              <a:t> effects of wildfire exposure on conflict outcomes at the district level in Indonesia.</a:t>
             </a:r>
-            <a:endParaRPr dirty="0"/>
           </a:p>
         </p:txBody>
       </p:sp>
@@ -16425,7 +14975,7 @@
           <p:nvPr/>
         </p:nvPicPr>
         <p:blipFill>
-          <a:blip r:embed="rId6"/>
+          <a:blip r:embed="rId5"/>
           <a:stretch>
             <a:fillRect/>
           </a:stretch>
@@ -16440,1441 +14990,6 @@
           </a:prstGeom>
         </p:spPr>
       </p:pic>
-      <mc:AlternateContent xmlns:mc="http://schemas.openxmlformats.org/markup-compatibility/2006" xmlns:a14="http://schemas.microsoft.com/office/drawing/2010/main">
-        <mc:Choice Requires="a14">
-          <p:sp>
-            <p:nvSpPr>
-              <p:cNvPr id="2" name="TextBox 1">
-                <a:extLst>
-                  <a:ext uri="{FF2B5EF4-FFF2-40B4-BE49-F238E27FC236}">
-                    <a16:creationId xmlns:a16="http://schemas.microsoft.com/office/drawing/2014/main" id="{7D7E1AB2-8033-B250-0C06-DF75CFA627B2}"/>
-                  </a:ext>
-                </a:extLst>
-              </p:cNvPr>
-              <p:cNvSpPr txBox="1"/>
-              <p:nvPr/>
-            </p:nvSpPr>
-            <p:spPr>
-              <a:xfrm>
-                <a:off x="11356985" y="25295172"/>
-                <a:ext cx="10493477" cy="538609"/>
-              </a:xfrm>
-              <a:prstGeom prst="rect">
-                <a:avLst/>
-              </a:prstGeom>
-              <a:noFill/>
-            </p:spPr>
-            <p:txBody>
-              <a:bodyPr wrap="square" lIns="0" tIns="0" rIns="0" bIns="0" rtlCol="0">
-                <a:spAutoFit/>
-              </a:bodyPr>
-              <a:lstStyle/>
-              <a:p>
-                <a:pPr/>
-                <a14:m>
-                  <m:oMathPara xmlns:m="http://schemas.openxmlformats.org/officeDocument/2006/math">
-                    <m:oMathParaPr>
-                      <m:jc m:val="centerGroup"/>
-                    </m:oMathParaPr>
-                    <m:oMath xmlns:m="http://schemas.openxmlformats.org/officeDocument/2006/math">
-                      <m:r>
-                        <a:rPr lang="en-US" sz="3500" b="0" i="1" smtClean="0">
-                          <a:latin typeface="Cambria Math" panose="02040503050406030204" pitchFamily="18" charset="0"/>
-                        </a:rPr>
-                        <m:t>𝑅𝑒𝑣𝑒𝑛𝑢</m:t>
-                      </m:r>
-                      <m:sSub>
-                        <m:sSubPr>
-                          <m:ctrlPr>
-                            <a:rPr lang="en-US" sz="3500" b="0" i="1" smtClean="0">
-                              <a:latin typeface="Cambria Math" panose="02040503050406030204" pitchFamily="18" charset="0"/>
-                            </a:rPr>
-                          </m:ctrlPr>
-                        </m:sSubPr>
-                        <m:e>
-                          <m:r>
-                            <a:rPr lang="en-US" sz="3500" b="0" i="1" smtClean="0">
-                              <a:latin typeface="Cambria Math" panose="02040503050406030204" pitchFamily="18" charset="0"/>
-                            </a:rPr>
-                            <m:t>𝑒</m:t>
-                          </m:r>
-                        </m:e>
-                        <m:sub>
-                          <m:r>
-                            <a:rPr lang="en-US" sz="3500" b="0" i="1" smtClean="0">
-                              <a:latin typeface="Cambria Math" panose="02040503050406030204" pitchFamily="18" charset="0"/>
-                            </a:rPr>
-                            <m:t>𝑖</m:t>
-                          </m:r>
-                        </m:sub>
-                      </m:sSub>
-                      <m:r>
-                        <a:rPr lang="en-US" sz="3500" b="0" i="1" smtClean="0">
-                          <a:latin typeface="Cambria Math" panose="02040503050406030204" pitchFamily="18" charset="0"/>
-                        </a:rPr>
-                        <m:t>=</m:t>
-                      </m:r>
-                      <m:sSub>
-                        <m:sSubPr>
-                          <m:ctrlPr>
-                            <a:rPr lang="en-US" sz="3500" b="0" i="1" smtClean="0">
-                              <a:latin typeface="Cambria Math" panose="02040503050406030204" pitchFamily="18" charset="0"/>
-                            </a:rPr>
-                          </m:ctrlPr>
-                        </m:sSubPr>
-                        <m:e>
-                          <m:r>
-                            <a:rPr lang="en-US" sz="3500" b="0" i="1" smtClean="0">
-                              <a:latin typeface="Cambria Math" panose="02040503050406030204" pitchFamily="18" charset="0"/>
-                            </a:rPr>
-                            <m:t>𝛼</m:t>
-                          </m:r>
-                        </m:e>
-                        <m:sub>
-                          <m:r>
-                            <a:rPr lang="en-US" sz="3500" b="0" i="1" smtClean="0">
-                              <a:latin typeface="Cambria Math" panose="02040503050406030204" pitchFamily="18" charset="0"/>
-                            </a:rPr>
-                            <m:t>𝑖</m:t>
-                          </m:r>
-                        </m:sub>
-                      </m:sSub>
-                      <m:r>
-                        <a:rPr lang="en-US" sz="3500" b="0" i="1" smtClean="0">
-                          <a:latin typeface="Cambria Math" panose="02040503050406030204" pitchFamily="18" charset="0"/>
-                        </a:rPr>
-                        <m:t>+</m:t>
-                      </m:r>
-                      <m:sSub>
-                        <m:sSubPr>
-                          <m:ctrlPr>
-                            <a:rPr lang="en-US" sz="3500" b="0" i="1" smtClean="0">
-                              <a:latin typeface="Cambria Math" panose="02040503050406030204" pitchFamily="18" charset="0"/>
-                            </a:rPr>
-                          </m:ctrlPr>
-                        </m:sSubPr>
-                        <m:e>
-                          <m:r>
-                            <a:rPr lang="en-US" sz="3500" b="0" i="1" smtClean="0">
-                              <a:latin typeface="Cambria Math" panose="02040503050406030204" pitchFamily="18" charset="0"/>
-                            </a:rPr>
-                            <m:t>𝛽</m:t>
-                          </m:r>
-                        </m:e>
-                        <m:sub>
-                          <m:r>
-                            <a:rPr lang="en-US" sz="3500" b="0" i="1" smtClean="0">
-                              <a:latin typeface="Cambria Math" panose="02040503050406030204" pitchFamily="18" charset="0"/>
-                            </a:rPr>
-                            <m:t>𝑖</m:t>
-                          </m:r>
-                        </m:sub>
-                      </m:sSub>
-                      <m:r>
-                        <a:rPr lang="en-US" sz="3500" b="0" i="1" smtClean="0">
-                          <a:latin typeface="Cambria Math" panose="02040503050406030204" pitchFamily="18" charset="0"/>
-                        </a:rPr>
-                        <m:t>𝐹𝑙𝑒𝑠𝑐</m:t>
-                      </m:r>
-                      <m:sSub>
-                        <m:sSubPr>
-                          <m:ctrlPr>
-                            <a:rPr lang="en-US" sz="3500" b="0" i="1" smtClean="0">
-                              <a:latin typeface="Cambria Math" panose="02040503050406030204" pitchFamily="18" charset="0"/>
-                            </a:rPr>
-                          </m:ctrlPr>
-                        </m:sSubPr>
-                        <m:e>
-                          <m:r>
-                            <a:rPr lang="en-US" sz="3500" b="0" i="1" smtClean="0">
-                              <a:latin typeface="Cambria Math" panose="02040503050406030204" pitchFamily="18" charset="0"/>
-                            </a:rPr>
-                            <m:t>h</m:t>
-                          </m:r>
-                        </m:e>
-                        <m:sub>
-                          <m:r>
-                            <a:rPr lang="en-US" sz="3500" b="0" i="1" smtClean="0">
-                              <a:latin typeface="Cambria Math" panose="02040503050406030204" pitchFamily="18" charset="0"/>
-                            </a:rPr>
-                            <m:t>𝑖</m:t>
-                          </m:r>
-                        </m:sub>
-                      </m:sSub>
-                      <m:r>
-                        <a:rPr lang="en-US" sz="3500" b="0" i="1" smtClean="0">
-                          <a:latin typeface="Cambria Math" panose="02040503050406030204" pitchFamily="18" charset="0"/>
-                        </a:rPr>
-                        <m:t>+</m:t>
-                      </m:r>
-                      <m:sSub>
-                        <m:sSubPr>
-                          <m:ctrlPr>
-                            <a:rPr lang="en-US" sz="3500" b="0" i="1" smtClean="0">
-                              <a:latin typeface="Cambria Math" panose="02040503050406030204" pitchFamily="18" charset="0"/>
-                            </a:rPr>
-                          </m:ctrlPr>
-                        </m:sSubPr>
-                        <m:e>
-                          <m:r>
-                            <a:rPr lang="en-US" sz="3500" b="0" i="1" smtClean="0">
-                              <a:latin typeface="Cambria Math" panose="02040503050406030204" pitchFamily="18" charset="0"/>
-                            </a:rPr>
-                            <m:t>𝜖</m:t>
-                          </m:r>
-                        </m:e>
-                        <m:sub>
-                          <m:r>
-                            <a:rPr lang="en-US" sz="3500" b="0" i="1" smtClean="0">
-                              <a:latin typeface="Cambria Math" panose="02040503050406030204" pitchFamily="18" charset="0"/>
-                            </a:rPr>
-                            <m:t>𝑖</m:t>
-                          </m:r>
-                        </m:sub>
-                      </m:sSub>
-                    </m:oMath>
-                  </m:oMathPara>
-                </a14:m>
-                <a:endParaRPr lang="en-US" sz="3500" dirty="0"/>
-              </a:p>
-            </p:txBody>
-          </p:sp>
-        </mc:Choice>
-        <mc:Fallback xmlns="">
-          <p:sp>
-            <p:nvSpPr>
-              <p:cNvPr id="2" name="TextBox 1">
-                <a:extLst>
-                  <a:ext uri="{FF2B5EF4-FFF2-40B4-BE49-F238E27FC236}">
-                    <a16:creationId xmlns:a16="http://schemas.microsoft.com/office/drawing/2014/main" id="{7D7E1AB2-8033-B250-0C06-DF75CFA627B2}"/>
-                  </a:ext>
-                </a:extLst>
-              </p:cNvPr>
-              <p:cNvSpPr txBox="1">
-                <a:spLocks noRot="1" noChangeAspect="1" noMove="1" noResize="1" noEditPoints="1" noAdjustHandles="1" noChangeArrowheads="1" noChangeShapeType="1" noTextEdit="1"/>
-              </p:cNvSpPr>
-              <p:nvPr/>
-            </p:nvSpPr>
-            <p:spPr>
-              <a:xfrm>
-                <a:off x="11356985" y="25295172"/>
-                <a:ext cx="10493477" cy="538609"/>
-              </a:xfrm>
-              <a:prstGeom prst="rect">
-                <a:avLst/>
-              </a:prstGeom>
-              <a:blipFill>
-                <a:blip r:embed="rId7"/>
-                <a:stretch>
-                  <a:fillRect/>
-                </a:stretch>
-              </a:blipFill>
-            </p:spPr>
-            <p:txBody>
-              <a:bodyPr/>
-              <a:lstStyle/>
-              <a:p>
-                <a:r>
-                  <a:rPr lang="en-US">
-                    <a:noFill/>
-                  </a:rPr>
-                  <a:t> </a:t>
-                </a:r>
-              </a:p>
-            </p:txBody>
-          </p:sp>
-        </mc:Fallback>
-      </mc:AlternateContent>
-      <p:pic>
-        <p:nvPicPr>
-          <p:cNvPr id="4" name="Picture 3">
-            <a:extLst>
-              <a:ext uri="{FF2B5EF4-FFF2-40B4-BE49-F238E27FC236}">
-                <a16:creationId xmlns:a16="http://schemas.microsoft.com/office/drawing/2014/main" id="{A09FCC25-E2AC-AE9F-2C65-58688AEA1119}"/>
-              </a:ext>
-            </a:extLst>
-          </p:cNvPr>
-          <p:cNvPicPr>
-            <a:picLocks noChangeAspect="1"/>
-          </p:cNvPicPr>
-          <p:nvPr/>
-        </p:nvPicPr>
-        <p:blipFill>
-          <a:blip r:embed="rId8"/>
-          <a:stretch>
-            <a:fillRect/>
-          </a:stretch>
-        </p:blipFill>
-        <p:spPr>
-          <a:xfrm>
-            <a:off x="11925390" y="19466713"/>
-            <a:ext cx="9383615" cy="5489775"/>
-          </a:xfrm>
-          <a:prstGeom prst="rect">
-            <a:avLst/>
-          </a:prstGeom>
-        </p:spPr>
-      </p:pic>
-      <p:pic>
-        <p:nvPicPr>
-          <p:cNvPr id="7" name="Picture 6">
-            <a:extLst>
-              <a:ext uri="{FF2B5EF4-FFF2-40B4-BE49-F238E27FC236}">
-                <a16:creationId xmlns:a16="http://schemas.microsoft.com/office/drawing/2014/main" id="{FFBDD742-4AF4-BE04-6165-F2C1F2975299}"/>
-              </a:ext>
-            </a:extLst>
-          </p:cNvPr>
-          <p:cNvPicPr>
-            <a:picLocks noChangeAspect="1"/>
-          </p:cNvPicPr>
-          <p:nvPr/>
-        </p:nvPicPr>
-        <p:blipFill>
-          <a:blip r:embed="rId9"/>
-          <a:stretch>
-            <a:fillRect/>
-          </a:stretch>
-        </p:blipFill>
-        <p:spPr>
-          <a:xfrm>
-            <a:off x="21786251" y="19466713"/>
-            <a:ext cx="9613381" cy="5624197"/>
-          </a:xfrm>
-          <a:prstGeom prst="rect">
-            <a:avLst/>
-          </a:prstGeom>
-        </p:spPr>
-      </p:pic>
-      <mc:AlternateContent xmlns:mc="http://schemas.openxmlformats.org/markup-compatibility/2006" xmlns:a14="http://schemas.microsoft.com/office/drawing/2010/main">
-        <mc:Choice Requires="a14">
-          <p:sp>
-            <p:nvSpPr>
-              <p:cNvPr id="8" name="TextBox 7">
-                <a:extLst>
-                  <a:ext uri="{FF2B5EF4-FFF2-40B4-BE49-F238E27FC236}">
-                    <a16:creationId xmlns:a16="http://schemas.microsoft.com/office/drawing/2014/main" id="{0B7D1384-4D48-0FD2-6023-C0F1037547FB}"/>
-                  </a:ext>
-                </a:extLst>
-              </p:cNvPr>
-              <p:cNvSpPr txBox="1"/>
-              <p:nvPr/>
-            </p:nvSpPr>
-            <p:spPr>
-              <a:xfrm>
-                <a:off x="21648836" y="25287945"/>
-                <a:ext cx="10493477" cy="538609"/>
-              </a:xfrm>
-              <a:prstGeom prst="rect">
-                <a:avLst/>
-              </a:prstGeom>
-              <a:noFill/>
-            </p:spPr>
-            <p:txBody>
-              <a:bodyPr wrap="square" lIns="0" tIns="0" rIns="0" bIns="0" rtlCol="0">
-                <a:spAutoFit/>
-              </a:bodyPr>
-              <a:lstStyle/>
-              <a:p>
-                <a:pPr/>
-                <a14:m>
-                  <m:oMathPara xmlns:m="http://schemas.openxmlformats.org/officeDocument/2006/math">
-                    <m:oMathParaPr>
-                      <m:jc m:val="centerGroup"/>
-                    </m:oMathParaPr>
-                    <m:oMath xmlns:m="http://schemas.openxmlformats.org/officeDocument/2006/math">
-                      <m:r>
-                        <a:rPr lang="en-US" sz="3500" b="0" i="1" smtClean="0">
-                          <a:latin typeface="Cambria Math" panose="02040503050406030204" pitchFamily="18" charset="0"/>
-                        </a:rPr>
-                        <m:t>𝑅𝑒𝑣𝑒𝑛𝑢</m:t>
-                      </m:r>
-                      <m:sSub>
-                        <m:sSubPr>
-                          <m:ctrlPr>
-                            <a:rPr lang="en-US" sz="3500" b="0" i="1" smtClean="0">
-                              <a:latin typeface="Cambria Math" panose="02040503050406030204" pitchFamily="18" charset="0"/>
-                            </a:rPr>
-                          </m:ctrlPr>
-                        </m:sSubPr>
-                        <m:e>
-                          <m:r>
-                            <a:rPr lang="en-US" sz="3500" b="0" i="1" smtClean="0">
-                              <a:latin typeface="Cambria Math" panose="02040503050406030204" pitchFamily="18" charset="0"/>
-                            </a:rPr>
-                            <m:t>𝑒</m:t>
-                          </m:r>
-                        </m:e>
-                        <m:sub>
-                          <m:r>
-                            <a:rPr lang="en-US" sz="3500" b="0" i="1" smtClean="0">
-                              <a:latin typeface="Cambria Math" panose="02040503050406030204" pitchFamily="18" charset="0"/>
-                            </a:rPr>
-                            <m:t>𝑖</m:t>
-                          </m:r>
-                        </m:sub>
-                      </m:sSub>
-                      <m:r>
-                        <a:rPr lang="en-US" sz="3500" b="0" i="1" smtClean="0">
-                          <a:latin typeface="Cambria Math" panose="02040503050406030204" pitchFamily="18" charset="0"/>
-                        </a:rPr>
-                        <m:t>=</m:t>
-                      </m:r>
-                      <m:sSub>
-                        <m:sSubPr>
-                          <m:ctrlPr>
-                            <a:rPr lang="en-US" sz="3500" b="0" i="1" smtClean="0">
-                              <a:latin typeface="Cambria Math" panose="02040503050406030204" pitchFamily="18" charset="0"/>
-                            </a:rPr>
-                          </m:ctrlPr>
-                        </m:sSubPr>
-                        <m:e>
-                          <m:r>
-                            <a:rPr lang="en-US" sz="3500" b="0" i="1" smtClean="0">
-                              <a:latin typeface="Cambria Math" panose="02040503050406030204" pitchFamily="18" charset="0"/>
-                            </a:rPr>
-                            <m:t>𝛼</m:t>
-                          </m:r>
-                        </m:e>
-                        <m:sub>
-                          <m:r>
-                            <a:rPr lang="en-US" sz="3500" b="0" i="1" smtClean="0">
-                              <a:latin typeface="Cambria Math" panose="02040503050406030204" pitchFamily="18" charset="0"/>
-                            </a:rPr>
-                            <m:t>𝑖</m:t>
-                          </m:r>
-                        </m:sub>
-                      </m:sSub>
-                      <m:r>
-                        <a:rPr lang="en-US" sz="3500" b="0" i="1" smtClean="0">
-                          <a:latin typeface="Cambria Math" panose="02040503050406030204" pitchFamily="18" charset="0"/>
-                        </a:rPr>
-                        <m:t>+</m:t>
-                      </m:r>
-                      <m:sSub>
-                        <m:sSubPr>
-                          <m:ctrlPr>
-                            <a:rPr lang="en-US" sz="3500" b="0" i="1" smtClean="0">
-                              <a:latin typeface="Cambria Math" panose="02040503050406030204" pitchFamily="18" charset="0"/>
-                            </a:rPr>
-                          </m:ctrlPr>
-                        </m:sSubPr>
-                        <m:e>
-                          <m:r>
-                            <a:rPr lang="en-US" sz="3500" b="0" i="1" smtClean="0">
-                              <a:latin typeface="Cambria Math" panose="02040503050406030204" pitchFamily="18" charset="0"/>
-                            </a:rPr>
-                            <m:t>𝛽</m:t>
-                          </m:r>
-                        </m:e>
-                        <m:sub>
-                          <m:r>
-                            <a:rPr lang="en-US" sz="3500" b="0" i="1" smtClean="0">
-                              <a:latin typeface="Cambria Math" panose="02040503050406030204" pitchFamily="18" charset="0"/>
-                            </a:rPr>
-                            <m:t>𝑖</m:t>
-                          </m:r>
-                        </m:sub>
-                      </m:sSub>
-                      <m:r>
-                        <a:rPr lang="en-US" sz="3500" b="0" i="1" smtClean="0">
-                          <a:latin typeface="Cambria Math" panose="02040503050406030204" pitchFamily="18" charset="0"/>
-                        </a:rPr>
-                        <m:t>𝐻𝑎𝑝𝑎</m:t>
-                      </m:r>
-                      <m:sSub>
-                        <m:sSubPr>
-                          <m:ctrlPr>
-                            <a:rPr lang="en-US" sz="3500" b="0" i="1" smtClean="0">
-                              <a:latin typeface="Cambria Math" panose="02040503050406030204" pitchFamily="18" charset="0"/>
-                            </a:rPr>
-                          </m:ctrlPr>
-                        </m:sSubPr>
-                        <m:e>
-                          <m:r>
-                            <a:rPr lang="en-US" sz="3500" b="0" i="1" smtClean="0">
-                              <a:latin typeface="Cambria Math" panose="02040503050406030204" pitchFamily="18" charset="0"/>
-                            </a:rPr>
-                            <m:t>𝑥</m:t>
-                          </m:r>
-                        </m:e>
-                        <m:sub>
-                          <m:r>
-                            <a:rPr lang="en-US" sz="3500" b="0" i="1" smtClean="0">
-                              <a:latin typeface="Cambria Math" panose="02040503050406030204" pitchFamily="18" charset="0"/>
-                            </a:rPr>
-                            <m:t>𝑖</m:t>
-                          </m:r>
-                        </m:sub>
-                      </m:sSub>
-                      <m:r>
-                        <a:rPr lang="en-US" sz="3500" b="0" i="1" smtClean="0">
-                          <a:latin typeface="Cambria Math" panose="02040503050406030204" pitchFamily="18" charset="0"/>
-                        </a:rPr>
-                        <m:t>+</m:t>
-                      </m:r>
-                      <m:sSub>
-                        <m:sSubPr>
-                          <m:ctrlPr>
-                            <a:rPr lang="en-US" sz="3500" b="0" i="1" smtClean="0">
-                              <a:latin typeface="Cambria Math" panose="02040503050406030204" pitchFamily="18" charset="0"/>
-                            </a:rPr>
-                          </m:ctrlPr>
-                        </m:sSubPr>
-                        <m:e>
-                          <m:r>
-                            <a:rPr lang="en-US" sz="3500" b="0" i="1" smtClean="0">
-                              <a:latin typeface="Cambria Math" panose="02040503050406030204" pitchFamily="18" charset="0"/>
-                            </a:rPr>
-                            <m:t>𝜖</m:t>
-                          </m:r>
-                        </m:e>
-                        <m:sub>
-                          <m:r>
-                            <a:rPr lang="en-US" sz="3500" b="0" i="1" smtClean="0">
-                              <a:latin typeface="Cambria Math" panose="02040503050406030204" pitchFamily="18" charset="0"/>
-                            </a:rPr>
-                            <m:t>𝑖</m:t>
-                          </m:r>
-                        </m:sub>
-                      </m:sSub>
-                    </m:oMath>
-                  </m:oMathPara>
-                </a14:m>
-                <a:endParaRPr lang="en-US" sz="3500" dirty="0"/>
-              </a:p>
-            </p:txBody>
-          </p:sp>
-        </mc:Choice>
-        <mc:Fallback xmlns="">
-          <p:sp>
-            <p:nvSpPr>
-              <p:cNvPr id="8" name="TextBox 7">
-                <a:extLst>
-                  <a:ext uri="{FF2B5EF4-FFF2-40B4-BE49-F238E27FC236}">
-                    <a16:creationId xmlns:a16="http://schemas.microsoft.com/office/drawing/2014/main" id="{0B7D1384-4D48-0FD2-6023-C0F1037547FB}"/>
-                  </a:ext>
-                </a:extLst>
-              </p:cNvPr>
-              <p:cNvSpPr txBox="1">
-                <a:spLocks noRot="1" noChangeAspect="1" noMove="1" noResize="1" noEditPoints="1" noAdjustHandles="1" noChangeArrowheads="1" noChangeShapeType="1" noTextEdit="1"/>
-              </p:cNvSpPr>
-              <p:nvPr/>
-            </p:nvSpPr>
-            <p:spPr>
-              <a:xfrm>
-                <a:off x="21648836" y="25287945"/>
-                <a:ext cx="10493477" cy="538609"/>
-              </a:xfrm>
-              <a:prstGeom prst="rect">
-                <a:avLst/>
-              </a:prstGeom>
-              <a:blipFill>
-                <a:blip r:embed="rId10"/>
-                <a:stretch>
-                  <a:fillRect/>
-                </a:stretch>
-              </a:blipFill>
-            </p:spPr>
-            <p:txBody>
-              <a:bodyPr/>
-              <a:lstStyle/>
-              <a:p>
-                <a:r>
-                  <a:rPr lang="en-US">
-                    <a:noFill/>
-                  </a:rPr>
-                  <a:t> </a:t>
-                </a:r>
-              </a:p>
-            </p:txBody>
-          </p:sp>
-        </mc:Fallback>
-      </mc:AlternateContent>
-      <p:graphicFrame>
-        <p:nvGraphicFramePr>
-          <p:cNvPr id="12" name="Table 11">
-            <a:extLst>
-              <a:ext uri="{FF2B5EF4-FFF2-40B4-BE49-F238E27FC236}">
-                <a16:creationId xmlns:a16="http://schemas.microsoft.com/office/drawing/2014/main" id="{AE49C644-9D36-EA05-FF38-AF1DBF4787AD}"/>
-              </a:ext>
-            </a:extLst>
-          </p:cNvPr>
-          <p:cNvGraphicFramePr>
-            <a:graphicFrameLocks noGrp="1"/>
-          </p:cNvGraphicFramePr>
-          <p:nvPr>
-            <p:extLst>
-              <p:ext uri="{D42A27DB-BD31-4B8C-83A1-F6EECF244321}">
-                <p14:modId xmlns:p14="http://schemas.microsoft.com/office/powerpoint/2010/main" val="2517924007"/>
-              </p:ext>
-            </p:extLst>
-          </p:nvPr>
-        </p:nvGraphicFramePr>
-        <p:xfrm>
-          <a:off x="12654542" y="26118775"/>
-          <a:ext cx="9184865" cy="1765557"/>
-        </p:xfrm>
-        <a:graphic>
-          <a:graphicData uri="http://schemas.openxmlformats.org/drawingml/2006/table">
-            <a:tbl>
-              <a:tblPr firstRow="1" bandRow="1">
-                <a:tableStyleId>{073A0DAA-6AF3-43AB-8588-CEC1D06C72B9}</a:tableStyleId>
-              </a:tblPr>
-              <a:tblGrid>
-                <a:gridCol w="1836973">
-                  <a:extLst>
-                    <a:ext uri="{9D8B030D-6E8A-4147-A177-3AD203B41FA5}">
-                      <a16:colId xmlns:a16="http://schemas.microsoft.com/office/drawing/2014/main" val="183964192"/>
-                    </a:ext>
-                  </a:extLst>
-                </a:gridCol>
-                <a:gridCol w="1836973">
-                  <a:extLst>
-                    <a:ext uri="{9D8B030D-6E8A-4147-A177-3AD203B41FA5}">
-                      <a16:colId xmlns:a16="http://schemas.microsoft.com/office/drawing/2014/main" val="1310211548"/>
-                    </a:ext>
-                  </a:extLst>
-                </a:gridCol>
-                <a:gridCol w="1836973">
-                  <a:extLst>
-                    <a:ext uri="{9D8B030D-6E8A-4147-A177-3AD203B41FA5}">
-                      <a16:colId xmlns:a16="http://schemas.microsoft.com/office/drawing/2014/main" val="2456665291"/>
-                    </a:ext>
-                  </a:extLst>
-                </a:gridCol>
-                <a:gridCol w="1836973">
-                  <a:extLst>
-                    <a:ext uri="{9D8B030D-6E8A-4147-A177-3AD203B41FA5}">
-                      <a16:colId xmlns:a16="http://schemas.microsoft.com/office/drawing/2014/main" val="3522645735"/>
-                    </a:ext>
-                  </a:extLst>
-                </a:gridCol>
-                <a:gridCol w="1836973">
-                  <a:extLst>
-                    <a:ext uri="{9D8B030D-6E8A-4147-A177-3AD203B41FA5}">
-                      <a16:colId xmlns:a16="http://schemas.microsoft.com/office/drawing/2014/main" val="2190784184"/>
-                    </a:ext>
-                  </a:extLst>
-                </a:gridCol>
-              </a:tblGrid>
-              <a:tr h="588519">
-                <a:tc>
-                  <a:txBody>
-                    <a:bodyPr/>
-                    <a:lstStyle/>
-                    <a:p>
-                      <a:r>
-                        <a:rPr lang="en-US" sz="2000" dirty="0"/>
-                        <a:t>Coefficients:</a:t>
-                      </a:r>
-                    </a:p>
-                  </a:txBody>
-                  <a:tcPr/>
-                </a:tc>
-                <a:tc>
-                  <a:txBody>
-                    <a:bodyPr/>
-                    <a:lstStyle/>
-                    <a:p>
-                      <a:r>
-                        <a:rPr lang="en-US" sz="2000" dirty="0"/>
-                        <a:t>Estimate</a:t>
-                      </a:r>
-                    </a:p>
-                  </a:txBody>
-                  <a:tcPr/>
-                </a:tc>
-                <a:tc>
-                  <a:txBody>
-                    <a:bodyPr/>
-                    <a:lstStyle/>
-                    <a:p>
-                      <a:r>
-                        <a:rPr lang="en-US" sz="2000" dirty="0"/>
-                        <a:t>Std. Error</a:t>
-                      </a:r>
-                    </a:p>
-                  </a:txBody>
-                  <a:tcPr/>
-                </a:tc>
-                <a:tc>
-                  <a:txBody>
-                    <a:bodyPr/>
-                    <a:lstStyle/>
-                    <a:p>
-                      <a:r>
-                        <a:rPr lang="en-US" sz="2000" dirty="0"/>
-                        <a:t>T-value</a:t>
-                      </a:r>
-                    </a:p>
-                  </a:txBody>
-                  <a:tcPr/>
-                </a:tc>
-                <a:tc>
-                  <a:txBody>
-                    <a:bodyPr/>
-                    <a:lstStyle/>
-                    <a:p>
-                      <a:r>
-                        <a:rPr lang="en-US" sz="2000" dirty="0"/>
-                        <a:t>P-value</a:t>
-                      </a:r>
-                    </a:p>
-                  </a:txBody>
-                  <a:tcPr/>
-                </a:tc>
-                <a:extLst>
-                  <a:ext uri="{0D108BD9-81ED-4DB2-BD59-A6C34878D82A}">
-                    <a16:rowId xmlns:a16="http://schemas.microsoft.com/office/drawing/2014/main" val="926823721"/>
-                  </a:ext>
-                </a:extLst>
-              </a:tr>
-              <a:tr h="588519">
-                <a:tc>
-                  <a:txBody>
-                    <a:bodyPr/>
-                    <a:lstStyle/>
-                    <a:p>
-                      <a:r>
-                        <a:rPr lang="en-US" sz="2000" dirty="0"/>
-                        <a:t>Intercept</a:t>
-                      </a:r>
-                    </a:p>
-                  </a:txBody>
-                  <a:tcPr/>
-                </a:tc>
-                <a:tc>
-                  <a:txBody>
-                    <a:bodyPr/>
-                    <a:lstStyle/>
-                    <a:p>
-                      <a:r>
-                        <a:rPr lang="en-US" sz="2000" dirty="0"/>
-                        <a:t>5259616</a:t>
-                      </a:r>
-                    </a:p>
-                  </a:txBody>
-                  <a:tcPr/>
-                </a:tc>
-                <a:tc>
-                  <a:txBody>
-                    <a:bodyPr/>
-                    <a:lstStyle/>
-                    <a:p>
-                      <a:r>
-                        <a:rPr lang="en-US" sz="2000" dirty="0"/>
-                        <a:t>336827</a:t>
-                      </a:r>
-                    </a:p>
-                  </a:txBody>
-                  <a:tcPr/>
-                </a:tc>
-                <a:tc>
-                  <a:txBody>
-                    <a:bodyPr/>
-                    <a:lstStyle/>
-                    <a:p>
-                      <a:r>
-                        <a:rPr lang="en-US" sz="2000" dirty="0"/>
-                        <a:t>15.615</a:t>
-                      </a:r>
-                    </a:p>
-                  </a:txBody>
-                  <a:tcPr/>
-                </a:tc>
-                <a:tc>
-                  <a:txBody>
-                    <a:bodyPr/>
-                    <a:lstStyle/>
-                    <a:p>
-                      <a:r>
-                        <a:rPr lang="en-US" sz="2000" dirty="0"/>
-                        <a:t>&lt; 2e^-16</a:t>
-                      </a:r>
-                    </a:p>
-                  </a:txBody>
-                  <a:tcPr/>
-                </a:tc>
-                <a:extLst>
-                  <a:ext uri="{0D108BD9-81ED-4DB2-BD59-A6C34878D82A}">
-                    <a16:rowId xmlns:a16="http://schemas.microsoft.com/office/drawing/2014/main" val="2811439347"/>
-                  </a:ext>
-                </a:extLst>
-              </a:tr>
-              <a:tr h="588519">
-                <a:tc>
-                  <a:txBody>
-                    <a:bodyPr/>
-                    <a:lstStyle/>
-                    <a:p>
-                      <a:r>
-                        <a:rPr lang="en-US" sz="2000" dirty="0"/>
-                        <a:t>Flesch Score</a:t>
-                      </a:r>
-                    </a:p>
-                  </a:txBody>
-                  <a:tcPr/>
-                </a:tc>
-                <a:tc>
-                  <a:txBody>
-                    <a:bodyPr/>
-                    <a:lstStyle/>
-                    <a:p>
-                      <a:r>
-                        <a:rPr lang="en-US" sz="2000" dirty="0"/>
-                        <a:t>34417</a:t>
-                      </a:r>
-                    </a:p>
-                  </a:txBody>
-                  <a:tcPr/>
-                </a:tc>
-                <a:tc>
-                  <a:txBody>
-                    <a:bodyPr/>
-                    <a:lstStyle/>
-                    <a:p>
-                      <a:r>
-                        <a:rPr lang="en-US" sz="2000" dirty="0"/>
-                        <a:t>10224</a:t>
-                      </a:r>
-                    </a:p>
-                  </a:txBody>
-                  <a:tcPr/>
-                </a:tc>
-                <a:tc>
-                  <a:txBody>
-                    <a:bodyPr/>
-                    <a:lstStyle/>
-                    <a:p>
-                      <a:r>
-                        <a:rPr lang="en-US" sz="2000" dirty="0"/>
-                        <a:t>3.366</a:t>
-                      </a:r>
-                    </a:p>
-                  </a:txBody>
-                  <a:tcPr/>
-                </a:tc>
-                <a:tc>
-                  <a:txBody>
-                    <a:bodyPr/>
-                    <a:lstStyle/>
-                    <a:p>
-                      <a:r>
-                        <a:rPr lang="en-US" sz="2000" dirty="0"/>
-                        <a:t>0.000762</a:t>
-                      </a:r>
-                    </a:p>
-                  </a:txBody>
-                  <a:tcPr/>
-                </a:tc>
-                <a:extLst>
-                  <a:ext uri="{0D108BD9-81ED-4DB2-BD59-A6C34878D82A}">
-                    <a16:rowId xmlns:a16="http://schemas.microsoft.com/office/drawing/2014/main" val="3123955569"/>
-                  </a:ext>
-                </a:extLst>
-              </a:tr>
-            </a:tbl>
-          </a:graphicData>
-        </a:graphic>
-      </p:graphicFrame>
-      <p:graphicFrame>
-        <p:nvGraphicFramePr>
-          <p:cNvPr id="13" name="Table 12">
-            <a:extLst>
-              <a:ext uri="{FF2B5EF4-FFF2-40B4-BE49-F238E27FC236}">
-                <a16:creationId xmlns:a16="http://schemas.microsoft.com/office/drawing/2014/main" id="{D142EB76-012D-6B36-3088-9759EA3E14BD}"/>
-              </a:ext>
-            </a:extLst>
-          </p:cNvPr>
-          <p:cNvGraphicFramePr>
-            <a:graphicFrameLocks noGrp="1"/>
-          </p:cNvGraphicFramePr>
-          <p:nvPr>
-            <p:extLst>
-              <p:ext uri="{D42A27DB-BD31-4B8C-83A1-F6EECF244321}">
-                <p14:modId xmlns:p14="http://schemas.microsoft.com/office/powerpoint/2010/main" val="1169831868"/>
-              </p:ext>
-            </p:extLst>
-          </p:nvPr>
-        </p:nvGraphicFramePr>
-        <p:xfrm>
-          <a:off x="22449882" y="26099516"/>
-          <a:ext cx="9228030" cy="1878078"/>
-        </p:xfrm>
-        <a:graphic>
-          <a:graphicData uri="http://schemas.openxmlformats.org/drawingml/2006/table">
-            <a:tbl>
-              <a:tblPr firstRow="1" bandRow="1">
-                <a:tableStyleId>{073A0DAA-6AF3-43AB-8588-CEC1D06C72B9}</a:tableStyleId>
-              </a:tblPr>
-              <a:tblGrid>
-                <a:gridCol w="1845606">
-                  <a:extLst>
-                    <a:ext uri="{9D8B030D-6E8A-4147-A177-3AD203B41FA5}">
-                      <a16:colId xmlns:a16="http://schemas.microsoft.com/office/drawing/2014/main" val="183964192"/>
-                    </a:ext>
-                  </a:extLst>
-                </a:gridCol>
-                <a:gridCol w="1845606">
-                  <a:extLst>
-                    <a:ext uri="{9D8B030D-6E8A-4147-A177-3AD203B41FA5}">
-                      <a16:colId xmlns:a16="http://schemas.microsoft.com/office/drawing/2014/main" val="1310211548"/>
-                    </a:ext>
-                  </a:extLst>
-                </a:gridCol>
-                <a:gridCol w="1845606">
-                  <a:extLst>
-                    <a:ext uri="{9D8B030D-6E8A-4147-A177-3AD203B41FA5}">
-                      <a16:colId xmlns:a16="http://schemas.microsoft.com/office/drawing/2014/main" val="2456665291"/>
-                    </a:ext>
-                  </a:extLst>
-                </a:gridCol>
-                <a:gridCol w="1845606">
-                  <a:extLst>
-                    <a:ext uri="{9D8B030D-6E8A-4147-A177-3AD203B41FA5}">
-                      <a16:colId xmlns:a16="http://schemas.microsoft.com/office/drawing/2014/main" val="3522645735"/>
-                    </a:ext>
-                  </a:extLst>
-                </a:gridCol>
-                <a:gridCol w="1845606">
-                  <a:extLst>
-                    <a:ext uri="{9D8B030D-6E8A-4147-A177-3AD203B41FA5}">
-                      <a16:colId xmlns:a16="http://schemas.microsoft.com/office/drawing/2014/main" val="2190784184"/>
-                    </a:ext>
-                  </a:extLst>
-                </a:gridCol>
-              </a:tblGrid>
-              <a:tr h="588519">
-                <a:tc>
-                  <a:txBody>
-                    <a:bodyPr/>
-                    <a:lstStyle/>
-                    <a:p>
-                      <a:r>
-                        <a:rPr lang="en-US" sz="2000" dirty="0"/>
-                        <a:t>Coefficients:</a:t>
-                      </a:r>
-                    </a:p>
-                  </a:txBody>
-                  <a:tcPr/>
-                </a:tc>
-                <a:tc>
-                  <a:txBody>
-                    <a:bodyPr/>
-                    <a:lstStyle/>
-                    <a:p>
-                      <a:r>
-                        <a:rPr lang="en-US" sz="2000" dirty="0"/>
-                        <a:t>Estimate</a:t>
-                      </a:r>
-                    </a:p>
-                  </a:txBody>
-                  <a:tcPr/>
-                </a:tc>
-                <a:tc>
-                  <a:txBody>
-                    <a:bodyPr/>
-                    <a:lstStyle/>
-                    <a:p>
-                      <a:r>
-                        <a:rPr lang="en-US" sz="2000" dirty="0"/>
-                        <a:t>Std. Error</a:t>
-                      </a:r>
-                    </a:p>
-                  </a:txBody>
-                  <a:tcPr/>
-                </a:tc>
-                <a:tc>
-                  <a:txBody>
-                    <a:bodyPr/>
-                    <a:lstStyle/>
-                    <a:p>
-                      <a:r>
-                        <a:rPr lang="en-US" sz="2000" dirty="0"/>
-                        <a:t>T-value</a:t>
-                      </a:r>
-                    </a:p>
-                  </a:txBody>
-                  <a:tcPr/>
-                </a:tc>
-                <a:tc>
-                  <a:txBody>
-                    <a:bodyPr/>
-                    <a:lstStyle/>
-                    <a:p>
-                      <a:r>
-                        <a:rPr lang="en-US" sz="2000" dirty="0"/>
-                        <a:t>P-value</a:t>
-                      </a:r>
-                    </a:p>
-                  </a:txBody>
-                  <a:tcPr/>
-                </a:tc>
-                <a:extLst>
-                  <a:ext uri="{0D108BD9-81ED-4DB2-BD59-A6C34878D82A}">
-                    <a16:rowId xmlns:a16="http://schemas.microsoft.com/office/drawing/2014/main" val="926823721"/>
-                  </a:ext>
-                </a:extLst>
-              </a:tr>
-              <a:tr h="588519">
-                <a:tc>
-                  <a:txBody>
-                    <a:bodyPr/>
-                    <a:lstStyle/>
-                    <a:p>
-                      <a:r>
-                        <a:rPr lang="en-US" sz="2000" dirty="0"/>
-                        <a:t>Intercept</a:t>
-                      </a:r>
-                    </a:p>
-                  </a:txBody>
-                  <a:tcPr/>
-                </a:tc>
-                <a:tc>
-                  <a:txBody>
-                    <a:bodyPr/>
-                    <a:lstStyle/>
-                    <a:p>
-                      <a:r>
-                        <a:rPr lang="en-US" sz="2000" dirty="0"/>
-                        <a:t>10571871</a:t>
-                      </a:r>
-                    </a:p>
-                  </a:txBody>
-                  <a:tcPr/>
-                </a:tc>
-                <a:tc>
-                  <a:txBody>
-                    <a:bodyPr/>
-                    <a:lstStyle/>
-                    <a:p>
-                      <a:r>
-                        <a:rPr lang="en-US" sz="2000" dirty="0"/>
-                        <a:t>1708334</a:t>
-                      </a:r>
-                    </a:p>
-                  </a:txBody>
-                  <a:tcPr/>
-                </a:tc>
-                <a:tc>
-                  <a:txBody>
-                    <a:bodyPr/>
-                    <a:lstStyle/>
-                    <a:p>
-                      <a:r>
-                        <a:rPr lang="en-US" sz="2000" dirty="0"/>
-                        <a:t>6.188</a:t>
-                      </a:r>
-                    </a:p>
-                  </a:txBody>
-                  <a:tcPr/>
-                </a:tc>
-                <a:tc>
-                  <a:txBody>
-                    <a:bodyPr/>
-                    <a:lstStyle/>
-                    <a:p>
-                      <a:r>
-                        <a:rPr lang="en-US" sz="2000" dirty="0"/>
-                        <a:t>6.1e^-10</a:t>
-                      </a:r>
-                    </a:p>
-                  </a:txBody>
-                  <a:tcPr/>
-                </a:tc>
-                <a:extLst>
-                  <a:ext uri="{0D108BD9-81ED-4DB2-BD59-A6C34878D82A}">
-                    <a16:rowId xmlns:a16="http://schemas.microsoft.com/office/drawing/2014/main" val="2811439347"/>
-                  </a:ext>
-                </a:extLst>
-              </a:tr>
-              <a:tr h="588519">
-                <a:tc>
-                  <a:txBody>
-                    <a:bodyPr/>
-                    <a:lstStyle/>
-                    <a:p>
-                      <a:r>
-                        <a:rPr lang="en-US" sz="2000" dirty="0"/>
-                        <a:t>Hapax Richness</a:t>
-                      </a:r>
-                    </a:p>
-                  </a:txBody>
-                  <a:tcPr/>
-                </a:tc>
-                <a:tc>
-                  <a:txBody>
-                    <a:bodyPr/>
-                    <a:lstStyle/>
-                    <a:p>
-                      <a:r>
-                        <a:rPr lang="en-US" sz="2000" dirty="0"/>
-                        <a:t>-5152904</a:t>
-                      </a:r>
-                    </a:p>
-                  </a:txBody>
-                  <a:tcPr/>
-                </a:tc>
-                <a:tc>
-                  <a:txBody>
-                    <a:bodyPr/>
-                    <a:lstStyle/>
-                    <a:p>
-                      <a:r>
-                        <a:rPr lang="en-US" sz="2000" dirty="0"/>
-                        <a:t>1893517</a:t>
-                      </a:r>
-                    </a:p>
-                  </a:txBody>
-                  <a:tcPr/>
-                </a:tc>
-                <a:tc>
-                  <a:txBody>
-                    <a:bodyPr/>
-                    <a:lstStyle/>
-                    <a:p>
-                      <a:r>
-                        <a:rPr lang="en-US" sz="2000" dirty="0"/>
-                        <a:t>-2.721</a:t>
-                      </a:r>
-                    </a:p>
-                  </a:txBody>
-                  <a:tcPr/>
-                </a:tc>
-                <a:tc>
-                  <a:txBody>
-                    <a:bodyPr/>
-                    <a:lstStyle/>
-                    <a:p>
-                      <a:r>
-                        <a:rPr lang="en-US" sz="2000" dirty="0"/>
-                        <a:t>0.0065</a:t>
-                      </a:r>
-                    </a:p>
-                  </a:txBody>
-                  <a:tcPr/>
-                </a:tc>
-                <a:extLst>
-                  <a:ext uri="{0D108BD9-81ED-4DB2-BD59-A6C34878D82A}">
-                    <a16:rowId xmlns:a16="http://schemas.microsoft.com/office/drawing/2014/main" val="3123955569"/>
-                  </a:ext>
-                </a:extLst>
-              </a:tr>
-            </a:tbl>
-          </a:graphicData>
-        </a:graphic>
-      </p:graphicFrame>
-      <p:graphicFrame>
-        <p:nvGraphicFramePr>
-          <p:cNvPr id="17" name="Table 16">
-            <a:extLst>
-              <a:ext uri="{FF2B5EF4-FFF2-40B4-BE49-F238E27FC236}">
-                <a16:creationId xmlns:a16="http://schemas.microsoft.com/office/drawing/2014/main" id="{8F14349A-38C7-43F4-7882-3DAFAD7AC63E}"/>
-              </a:ext>
-            </a:extLst>
-          </p:cNvPr>
-          <p:cNvGraphicFramePr>
-            <a:graphicFrameLocks noGrp="1"/>
-          </p:cNvGraphicFramePr>
-          <p:nvPr>
-            <p:extLst>
-              <p:ext uri="{D42A27DB-BD31-4B8C-83A1-F6EECF244321}">
-                <p14:modId xmlns:p14="http://schemas.microsoft.com/office/powerpoint/2010/main" val="3714982079"/>
-              </p:ext>
-            </p:extLst>
-          </p:nvPr>
-        </p:nvGraphicFramePr>
-        <p:xfrm>
-          <a:off x="12557266" y="28074571"/>
-          <a:ext cx="19213273" cy="3940622"/>
-        </p:xfrm>
-        <a:graphic>
-          <a:graphicData uri="http://schemas.openxmlformats.org/drawingml/2006/table">
-            <a:tbl>
-              <a:tblPr firstRow="1" bandRow="1">
-                <a:tableStyleId>{073A0DAA-6AF3-43AB-8588-CEC1D06C72B9}</a:tableStyleId>
-              </a:tblPr>
-              <a:tblGrid>
-                <a:gridCol w="3370374">
-                  <a:extLst>
-                    <a:ext uri="{9D8B030D-6E8A-4147-A177-3AD203B41FA5}">
-                      <a16:colId xmlns:a16="http://schemas.microsoft.com/office/drawing/2014/main" val="989323731"/>
-                    </a:ext>
-                  </a:extLst>
-                </a:gridCol>
-                <a:gridCol w="1541505">
-                  <a:extLst>
-                    <a:ext uri="{9D8B030D-6E8A-4147-A177-3AD203B41FA5}">
-                      <a16:colId xmlns:a16="http://schemas.microsoft.com/office/drawing/2014/main" val="4087679865"/>
-                    </a:ext>
-                  </a:extLst>
-                </a:gridCol>
-                <a:gridCol w="1956223">
-                  <a:extLst>
-                    <a:ext uri="{9D8B030D-6E8A-4147-A177-3AD203B41FA5}">
-                      <a16:colId xmlns:a16="http://schemas.microsoft.com/office/drawing/2014/main" val="3513889336"/>
-                    </a:ext>
-                  </a:extLst>
-                </a:gridCol>
-                <a:gridCol w="12345171">
-                  <a:extLst>
-                    <a:ext uri="{9D8B030D-6E8A-4147-A177-3AD203B41FA5}">
-                      <a16:colId xmlns:a16="http://schemas.microsoft.com/office/drawing/2014/main" val="3809310180"/>
-                    </a:ext>
-                  </a:extLst>
-                </a:gridCol>
-              </a:tblGrid>
-              <a:tr h="679262">
-                <a:tc>
-                  <a:txBody>
-                    <a:bodyPr/>
-                    <a:lstStyle/>
-                    <a:p>
-                      <a:r>
-                        <a:rPr lang="en-US" sz="2800" dirty="0"/>
-                        <a:t>Name</a:t>
-                      </a:r>
-                    </a:p>
-                  </a:txBody>
-                  <a:tcPr/>
-                </a:tc>
-                <a:tc>
-                  <a:txBody>
-                    <a:bodyPr/>
-                    <a:lstStyle/>
-                    <a:p>
-                      <a:r>
-                        <a:rPr lang="en-US" sz="2800" dirty="0"/>
-                        <a:t>NTEE</a:t>
-                      </a:r>
-                    </a:p>
-                  </a:txBody>
-                  <a:tcPr/>
-                </a:tc>
-                <a:tc>
-                  <a:txBody>
-                    <a:bodyPr/>
-                    <a:lstStyle/>
-                    <a:p>
-                      <a:r>
-                        <a:rPr lang="en-US" sz="2800" dirty="0"/>
-                        <a:t>Revenue</a:t>
-                      </a:r>
-                    </a:p>
-                  </a:txBody>
-                  <a:tcPr/>
-                </a:tc>
-                <a:tc>
-                  <a:txBody>
-                    <a:bodyPr/>
-                    <a:lstStyle/>
-                    <a:p>
-                      <a:r>
-                        <a:rPr lang="en-US" sz="2800" dirty="0"/>
-                        <a:t>Preprocessed Mission</a:t>
-                      </a:r>
-                    </a:p>
-                  </a:txBody>
-                  <a:tcPr/>
-                </a:tc>
-                <a:extLst>
-                  <a:ext uri="{0D108BD9-81ED-4DB2-BD59-A6C34878D82A}">
-                    <a16:rowId xmlns:a16="http://schemas.microsoft.com/office/drawing/2014/main" val="695158152"/>
-                  </a:ext>
-                </a:extLst>
-              </a:tr>
-              <a:tr h="679262">
-                <a:tc>
-                  <a:txBody>
-                    <a:bodyPr/>
-                    <a:lstStyle/>
-                    <a:p>
-                      <a:r>
-                        <a:rPr lang="en-US" sz="2800" dirty="0"/>
-                        <a:t>Alaska Veterans Museum</a:t>
-                      </a:r>
-                    </a:p>
-                  </a:txBody>
-                  <a:tcPr/>
-                </a:tc>
-                <a:tc>
-                  <a:txBody>
-                    <a:bodyPr/>
-                    <a:lstStyle/>
-                    <a:p>
-                      <a:r>
-                        <a:rPr lang="en-US" sz="2800" dirty="0"/>
-                        <a:t>A54</a:t>
-                      </a:r>
-                    </a:p>
-                  </a:txBody>
-                  <a:tcPr/>
-                </a:tc>
-                <a:tc>
-                  <a:txBody>
-                    <a:bodyPr/>
-                    <a:lstStyle/>
-                    <a:p>
-                      <a:r>
-                        <a:rPr lang="en-US" sz="2800" dirty="0"/>
-                        <a:t>$99949</a:t>
-                      </a:r>
-                    </a:p>
-                  </a:txBody>
-                  <a:tcPr/>
-                </a:tc>
-                <a:tc>
-                  <a:txBody>
-                    <a:bodyPr/>
-                    <a:lstStyle/>
-                    <a:p>
-                      <a:r>
-                        <a:rPr lang="en-US" sz="2800" dirty="0"/>
-                        <a:t>create museum inspiration, remembrance preservation veterans sacrifices </a:t>
-                      </a:r>
-                      <a:r>
-                        <a:rPr lang="en-US" sz="2800" dirty="0" err="1"/>
-                        <a:t>america</a:t>
-                      </a:r>
-                      <a:r>
-                        <a:rPr lang="en-US" sz="2800" dirty="0"/>
-                        <a:t> freedom</a:t>
-                      </a:r>
-                    </a:p>
-                  </a:txBody>
-                  <a:tcPr/>
-                </a:tc>
-                <a:extLst>
-                  <a:ext uri="{0D108BD9-81ED-4DB2-BD59-A6C34878D82A}">
-                    <a16:rowId xmlns:a16="http://schemas.microsoft.com/office/drawing/2014/main" val="4133675837"/>
-                  </a:ext>
-                </a:extLst>
-              </a:tr>
-              <a:tr h="679262">
-                <a:tc>
-                  <a:txBody>
-                    <a:bodyPr/>
-                    <a:lstStyle/>
-                    <a:p>
-                      <a:r>
-                        <a:rPr lang="en-US" sz="2800" dirty="0"/>
-                        <a:t>Alaska Childrens Alliance</a:t>
-                      </a:r>
-                    </a:p>
-                  </a:txBody>
-                  <a:tcPr/>
-                </a:tc>
-                <a:tc>
-                  <a:txBody>
-                    <a:bodyPr/>
-                    <a:lstStyle/>
-                    <a:p>
-                      <a:r>
-                        <a:rPr lang="en-US" sz="2800" dirty="0"/>
-                        <a:t>I72</a:t>
-                      </a:r>
-                    </a:p>
-                  </a:txBody>
-                  <a:tcPr/>
-                </a:tc>
-                <a:tc>
-                  <a:txBody>
-                    <a:bodyPr/>
-                    <a:lstStyle/>
-                    <a:p>
-                      <a:r>
-                        <a:rPr lang="en-US" sz="2800" dirty="0"/>
-                        <a:t>333022</a:t>
-                      </a:r>
-                    </a:p>
-                  </a:txBody>
-                  <a:tcPr/>
-                </a:tc>
-                <a:tc>
-                  <a:txBody>
-                    <a:bodyPr/>
-                    <a:lstStyle/>
-                    <a:p>
-                      <a:r>
-                        <a:rPr lang="en-US" sz="2800" dirty="0"/>
-                        <a:t>dedicate strengthen multi-disciplinary response child abuse.</a:t>
-                      </a:r>
-                    </a:p>
-                  </a:txBody>
-                  <a:tcPr/>
-                </a:tc>
-                <a:extLst>
-                  <a:ext uri="{0D108BD9-81ED-4DB2-BD59-A6C34878D82A}">
-                    <a16:rowId xmlns:a16="http://schemas.microsoft.com/office/drawing/2014/main" val="3585294609"/>
-                  </a:ext>
-                </a:extLst>
-              </a:tr>
-              <a:tr h="679262">
-                <a:tc>
-                  <a:txBody>
-                    <a:bodyPr/>
-                    <a:lstStyle/>
-                    <a:p>
-                      <a:r>
-                        <a:rPr lang="en-US" sz="2800" dirty="0"/>
-                        <a:t>Sacred Valley Health</a:t>
-                      </a:r>
-                    </a:p>
-                  </a:txBody>
-                  <a:tcPr/>
-                </a:tc>
-                <a:tc>
-                  <a:txBody>
-                    <a:bodyPr/>
-                    <a:lstStyle/>
-                    <a:p>
-                      <a:r>
-                        <a:rPr lang="en-US" sz="2800" dirty="0"/>
-                        <a:t>Q33</a:t>
-                      </a:r>
-                    </a:p>
-                    <a:p>
-                      <a:endParaRPr lang="en-US" sz="2800" dirty="0"/>
-                    </a:p>
-                  </a:txBody>
-                  <a:tcPr/>
-                </a:tc>
-                <a:tc>
-                  <a:txBody>
-                    <a:bodyPr/>
-                    <a:lstStyle/>
-                    <a:p>
-                      <a:r>
-                        <a:rPr lang="en-US" sz="2800" dirty="0"/>
-                        <a:t>173068</a:t>
-                      </a:r>
-                    </a:p>
-                  </a:txBody>
-                  <a:tcPr/>
-                </a:tc>
-                <a:tc>
-                  <a:txBody>
-                    <a:bodyPr/>
-                    <a:lstStyle/>
-                    <a:p>
-                      <a:r>
-                        <a:rPr lang="en-US" sz="2800" dirty="0"/>
-                        <a:t>mission Sacred Valley Health improve health under-served rural of Peru's Sacred through health and education increased access to health services community empowerment</a:t>
-                      </a:r>
-                    </a:p>
-                  </a:txBody>
-                  <a:tcPr/>
-                </a:tc>
-                <a:extLst>
-                  <a:ext uri="{0D108BD9-81ED-4DB2-BD59-A6C34878D82A}">
-                    <a16:rowId xmlns:a16="http://schemas.microsoft.com/office/drawing/2014/main" val="204093237"/>
-                  </a:ext>
-                </a:extLst>
-              </a:tr>
-            </a:tbl>
-          </a:graphicData>
-        </a:graphic>
-      </p:graphicFrame>
     </p:spTree>
   </p:cSld>
   <p:clrMapOvr>

</xml_diff>